<commit_message>
Diagnosed pretraining problem, generalisation failing because Q-values are too small
</commit_message>
<xml_diff>
--- a/docs/Project A1 Poster.pptx
+++ b/docs/Project A1 Poster.pptx
@@ -2955,8 +2955,8 @@
         </p:nvSpPr>
         <p:spPr>
           <a:xfrm>
-            <a:off x="0" y="-18893"/>
-            <a:ext cx="21383625" cy="3524093"/>
+            <a:off x="0" y="-18892"/>
+            <a:ext cx="21383625" cy="2812501"/>
           </a:xfrm>
           <a:prstGeom prst="rect">
             <a:avLst/>
@@ -3008,7 +3008,7 @@
         </p:nvSpPr>
         <p:spPr>
           <a:xfrm>
-            <a:off x="4200911" y="390060"/>
+            <a:off x="3825656" y="107826"/>
             <a:ext cx="16489458" cy="2635261"/>
           </a:xfrm>
         </p:spPr>
@@ -3074,8 +3074,8 @@
         </p:blipFill>
         <p:spPr bwMode="auto">
           <a:xfrm>
-            <a:off x="241611" y="65831"/>
-            <a:ext cx="3465948" cy="3330691"/>
+            <a:off x="693255" y="107826"/>
+            <a:ext cx="2665712" cy="2561684"/>
           </a:xfrm>
           <a:prstGeom prst="rect">
             <a:avLst/>
@@ -3094,45 +3094,6 @@
       </p:pic>
       <p:sp>
         <p:nvSpPr>
-          <p:cNvPr id="14" name="TextBox 13">
-            <a:extLst>
-              <a:ext uri="{FF2B5EF4-FFF2-40B4-BE49-F238E27FC236}">
-                <a16:creationId xmlns:a16="http://schemas.microsoft.com/office/drawing/2014/main" id="{EB91B601-77FE-C194-D7C2-468E93837BB8}"/>
-              </a:ext>
-            </a:extLst>
-          </p:cNvPr>
-          <p:cNvSpPr txBox="1"/>
-          <p:nvPr/>
-        </p:nvSpPr>
-        <p:spPr>
-          <a:xfrm>
-            <a:off x="570593" y="10666194"/>
-            <a:ext cx="19997114" cy="8182785"/>
-          </a:xfrm>
-          <a:prstGeom prst="roundRect">
-            <a:avLst/>
-          </a:prstGeom>
-          <a:solidFill>
-            <a:schemeClr val="bg1"/>
-          </a:solidFill>
-          <a:ln>
-            <a:solidFill>
-              <a:schemeClr val="accent1"/>
-            </a:solidFill>
-          </a:ln>
-        </p:spPr>
-        <p:txBody>
-          <a:bodyPr wrap="square" rtlCol="0">
-            <a:noAutofit/>
-          </a:bodyPr>
-          <a:lstStyle/>
-          <a:p>
-            <a:endParaRPr lang="en-GB" dirty="0"/>
-          </a:p>
-        </p:txBody>
-      </p:sp>
-      <p:sp>
-        <p:nvSpPr>
           <p:cNvPr id="15" name="TextBox 14">
             <a:extLst>
               <a:ext uri="{FF2B5EF4-FFF2-40B4-BE49-F238E27FC236}">
@@ -3163,90 +3124,12 @@
           </a:p>
         </p:txBody>
       </p:sp>
-      <p:sp>
-        <p:nvSpPr>
-          <p:cNvPr id="20" name="TextBox 19">
+      <p:grpSp>
+        <p:nvGrpSpPr>
+          <p:cNvPr id="16" name="Group 15">
             <a:extLst>
               <a:ext uri="{FF2B5EF4-FFF2-40B4-BE49-F238E27FC236}">
-                <a16:creationId xmlns:a16="http://schemas.microsoft.com/office/drawing/2014/main" id="{1E03E00E-8E28-7868-2FEA-6F77FB579AF7}"/>
-              </a:ext>
-            </a:extLst>
-          </p:cNvPr>
-          <p:cNvSpPr txBox="1"/>
-          <p:nvPr/>
-        </p:nvSpPr>
-        <p:spPr>
-          <a:xfrm>
-            <a:off x="693255" y="27437525"/>
-            <a:ext cx="19751791" cy="2447628"/>
-          </a:xfrm>
-          <a:prstGeom prst="roundRect">
-            <a:avLst/>
-          </a:prstGeom>
-          <a:solidFill>
-            <a:schemeClr val="bg1"/>
-          </a:solidFill>
-          <a:ln>
-            <a:solidFill>
-              <a:schemeClr val="accent1"/>
-            </a:solidFill>
-          </a:ln>
-        </p:spPr>
-        <p:txBody>
-          <a:bodyPr wrap="square" rtlCol="0">
-            <a:noAutofit/>
-          </a:bodyPr>
-          <a:lstStyle/>
-          <a:p>
-            <a:endParaRPr lang="en-GB" dirty="0"/>
-          </a:p>
-        </p:txBody>
-      </p:sp>
-      <p:sp>
-        <p:nvSpPr>
-          <p:cNvPr id="12" name="TextBox 11">
-            <a:extLst>
-              <a:ext uri="{FF2B5EF4-FFF2-40B4-BE49-F238E27FC236}">
-                <a16:creationId xmlns:a16="http://schemas.microsoft.com/office/drawing/2014/main" id="{5F7ADA20-BAB6-6E7F-17BB-882BF96EEBDD}"/>
-              </a:ext>
-            </a:extLst>
-          </p:cNvPr>
-          <p:cNvSpPr txBox="1"/>
-          <p:nvPr/>
-        </p:nvSpPr>
-        <p:spPr>
-          <a:xfrm>
-            <a:off x="693255" y="19051859"/>
-            <a:ext cx="19997114" cy="8182785"/>
-          </a:xfrm>
-          <a:prstGeom prst="roundRect">
-            <a:avLst/>
-          </a:prstGeom>
-          <a:solidFill>
-            <a:schemeClr val="bg1"/>
-          </a:solidFill>
-          <a:ln>
-            <a:solidFill>
-              <a:schemeClr val="accent1"/>
-            </a:solidFill>
-          </a:ln>
-        </p:spPr>
-        <p:txBody>
-          <a:bodyPr wrap="square" rtlCol="0">
-            <a:noAutofit/>
-          </a:bodyPr>
-          <a:lstStyle/>
-          <a:p>
-            <a:endParaRPr lang="en-GB" dirty="0"/>
-          </a:p>
-        </p:txBody>
-      </p:sp>
-      <p:grpSp>
-        <p:nvGrpSpPr>
-          <p:cNvPr id="22" name="Group 21">
-            <a:extLst>
-              <a:ext uri="{FF2B5EF4-FFF2-40B4-BE49-F238E27FC236}">
-                <a16:creationId xmlns:a16="http://schemas.microsoft.com/office/drawing/2014/main" id="{6DB9F096-8FB2-0F13-21D3-A0A3D8856AA0}"/>
+                <a16:creationId xmlns:a16="http://schemas.microsoft.com/office/drawing/2014/main" id="{7BB69EF9-B2A1-59F7-B709-5662B89D809C}"/>
               </a:ext>
             </a:extLst>
           </p:cNvPr>
@@ -3255,18 +3138,18 @@
         </p:nvGrpSpPr>
         <p:grpSpPr>
           <a:xfrm>
-            <a:off x="570592" y="4006486"/>
-            <a:ext cx="9807848" cy="6510696"/>
-            <a:chOff x="570592" y="4006486"/>
-            <a:chExt cx="9807848" cy="6510696"/>
+            <a:off x="422116" y="8143714"/>
+            <a:ext cx="20534520" cy="7357422"/>
+            <a:chOff x="570591" y="10666194"/>
+            <a:chExt cx="19997116" cy="8182785"/>
           </a:xfrm>
         </p:grpSpPr>
         <p:sp>
           <p:nvSpPr>
-            <p:cNvPr id="9" name="TextBox 8">
+            <p:cNvPr id="14" name="TextBox 13">
               <a:extLst>
                 <a:ext uri="{FF2B5EF4-FFF2-40B4-BE49-F238E27FC236}">
-                  <a16:creationId xmlns:a16="http://schemas.microsoft.com/office/drawing/2014/main" id="{BD174AE8-AF0B-34A4-7717-7077F0ACB2D9}"/>
+                  <a16:creationId xmlns:a16="http://schemas.microsoft.com/office/drawing/2014/main" id="{EB91B601-77FE-C194-D7C2-468E93837BB8}"/>
                 </a:ext>
               </a:extLst>
             </p:cNvPr>
@@ -3275,8 +3158,8 @@
           </p:nvSpPr>
           <p:spPr>
             <a:xfrm>
-              <a:off x="570592" y="4006486"/>
-              <a:ext cx="9807847" cy="6510696"/>
+              <a:off x="570593" y="10666194"/>
+              <a:ext cx="19997114" cy="8182785"/>
             </a:xfrm>
             <a:prstGeom prst="roundRect">
               <a:avLst/>
@@ -3302,10 +3185,10 @@
         </p:sp>
         <p:sp>
           <p:nvSpPr>
-            <p:cNvPr id="21" name="Rectangle: Top Corners Rounded 20">
+            <p:cNvPr id="23" name="Rectangle: Top Corners Rounded 22">
               <a:extLst>
                 <a:ext uri="{FF2B5EF4-FFF2-40B4-BE49-F238E27FC236}">
-                  <a16:creationId xmlns:a16="http://schemas.microsoft.com/office/drawing/2014/main" id="{CEA43005-15C9-DD71-26B3-326FF054B01A}"/>
+                  <a16:creationId xmlns:a16="http://schemas.microsoft.com/office/drawing/2014/main" id="{F1A5F185-2403-2C11-4F6E-69A4A5EC3DF5}"/>
                 </a:ext>
               </a:extLst>
             </p:cNvPr>
@@ -3314,8 +3197,8 @@
           </p:nvSpPr>
           <p:spPr>
             <a:xfrm>
-              <a:off x="570594" y="4006486"/>
-              <a:ext cx="9807846" cy="1022714"/>
+              <a:off x="570591" y="10666194"/>
+              <a:ext cx="19997113" cy="1304393"/>
             </a:xfrm>
             <a:prstGeom prst="round2SameRect">
               <a:avLst/>
@@ -3350,137 +3233,21 @@
                   <a:latin typeface="Source Sans Pro Black" panose="020F0502020204030204" pitchFamily="34" charset="0"/>
                   <a:ea typeface="Source Sans Pro Black" panose="020F0502020204030204" pitchFamily="34" charset="0"/>
                 </a:rPr>
-                <a:t>Motivation</a:t>
+                <a:t>Methodology</a:t>
               </a:r>
-              <a:endParaRPr lang="en-GB" sz="3200" dirty="0">
+              <a:endParaRPr lang="en-GB" sz="4000" dirty="0">
                 <a:latin typeface="Source Sans Pro Black" panose="020F0502020204030204" pitchFamily="34" charset="0"/>
               </a:endParaRPr>
             </a:p>
           </p:txBody>
         </p:sp>
       </p:grpSp>
-      <p:sp>
-        <p:nvSpPr>
-          <p:cNvPr id="23" name="Rectangle: Top Corners Rounded 22">
+      <p:grpSp>
+        <p:nvGrpSpPr>
+          <p:cNvPr id="17" name="Group 16">
             <a:extLst>
               <a:ext uri="{FF2B5EF4-FFF2-40B4-BE49-F238E27FC236}">
-                <a16:creationId xmlns:a16="http://schemas.microsoft.com/office/drawing/2014/main" id="{F1A5F185-2403-2C11-4F6E-69A4A5EC3DF5}"/>
-              </a:ext>
-            </a:extLst>
-          </p:cNvPr>
-          <p:cNvSpPr/>
-          <p:nvPr/>
-        </p:nvSpPr>
-        <p:spPr>
-          <a:xfrm>
-            <a:off x="570591" y="10666194"/>
-            <a:ext cx="19997113" cy="1304393"/>
-          </a:xfrm>
-          <a:prstGeom prst="round2SameRect">
-            <a:avLst/>
-          </a:prstGeom>
-          <a:solidFill>
-            <a:srgbClr val="07453F"/>
-          </a:solidFill>
-        </p:spPr>
-        <p:style>
-          <a:lnRef idx="2">
-            <a:schemeClr val="accent1">
-              <a:shade val="15000"/>
-            </a:schemeClr>
-          </a:lnRef>
-          <a:fillRef idx="1">
-            <a:schemeClr val="accent1"/>
-          </a:fillRef>
-          <a:effectRef idx="0">
-            <a:schemeClr val="accent1"/>
-          </a:effectRef>
-          <a:fontRef idx="minor">
-            <a:schemeClr val="lt1"/>
-          </a:fontRef>
-        </p:style>
-        <p:txBody>
-          <a:bodyPr rtlCol="0" anchor="ctr"/>
-          <a:lstStyle/>
-          <a:p>
-            <a:pPr algn="ctr"/>
-            <a:r>
-              <a:rPr lang="en-GB" sz="4000" dirty="0">
-                <a:latin typeface="Source Sans Pro Black" panose="020F0502020204030204" pitchFamily="34" charset="0"/>
-                <a:ea typeface="Source Sans Pro Black" panose="020F0502020204030204" pitchFamily="34" charset="0"/>
-              </a:rPr>
-              <a:t>Methodology</a:t>
-            </a:r>
-            <a:endParaRPr lang="en-GB" sz="4000" dirty="0">
-              <a:latin typeface="Source Sans Pro Black" panose="020F0502020204030204" pitchFamily="34" charset="0"/>
-            </a:endParaRPr>
-          </a:p>
-        </p:txBody>
-      </p:sp>
-      <p:sp>
-        <p:nvSpPr>
-          <p:cNvPr id="24" name="Rectangle: Top Corners Rounded 23">
-            <a:extLst>
-              <a:ext uri="{FF2B5EF4-FFF2-40B4-BE49-F238E27FC236}">
-                <a16:creationId xmlns:a16="http://schemas.microsoft.com/office/drawing/2014/main" id="{A0C196ED-0F01-28DC-4022-F460723A87BB}"/>
-              </a:ext>
-            </a:extLst>
-          </p:cNvPr>
-          <p:cNvSpPr/>
-          <p:nvPr/>
-        </p:nvSpPr>
-        <p:spPr>
-          <a:xfrm>
-            <a:off x="693256" y="19051859"/>
-            <a:ext cx="19997113" cy="1247714"/>
-          </a:xfrm>
-          <a:prstGeom prst="round2SameRect">
-            <a:avLst/>
-          </a:prstGeom>
-          <a:solidFill>
-            <a:srgbClr val="07453F"/>
-          </a:solidFill>
-        </p:spPr>
-        <p:style>
-          <a:lnRef idx="2">
-            <a:schemeClr val="accent1">
-              <a:shade val="15000"/>
-            </a:schemeClr>
-          </a:lnRef>
-          <a:fillRef idx="1">
-            <a:schemeClr val="accent1"/>
-          </a:fillRef>
-          <a:effectRef idx="0">
-            <a:schemeClr val="accent1"/>
-          </a:effectRef>
-          <a:fontRef idx="minor">
-            <a:schemeClr val="lt1"/>
-          </a:fontRef>
-        </p:style>
-        <p:txBody>
-          <a:bodyPr rtlCol="0" anchor="ctr"/>
-          <a:lstStyle/>
-          <a:p>
-            <a:pPr algn="ctr"/>
-            <a:r>
-              <a:rPr lang="en-GB" sz="4000" dirty="0">
-                <a:latin typeface="Source Sans Pro Black" panose="020F0502020204030204" pitchFamily="34" charset="0"/>
-                <a:ea typeface="Source Sans Pro Black" panose="020F0502020204030204" pitchFamily="34" charset="0"/>
-              </a:rPr>
-              <a:t>Methodology</a:t>
-            </a:r>
-            <a:endParaRPr lang="en-GB" sz="4000" dirty="0">
-              <a:latin typeface="Source Sans Pro Black" panose="020F0502020204030204" pitchFamily="34" charset="0"/>
-            </a:endParaRPr>
-          </a:p>
-        </p:txBody>
-      </p:sp>
-      <p:grpSp>
-        <p:nvGrpSpPr>
-          <p:cNvPr id="3" name="Group 2">
-            <a:extLst>
-              <a:ext uri="{FF2B5EF4-FFF2-40B4-BE49-F238E27FC236}">
-                <a16:creationId xmlns:a16="http://schemas.microsoft.com/office/drawing/2014/main" id="{15284BD6-DD07-071F-83B7-F71BFC2DC062}"/>
+                <a16:creationId xmlns:a16="http://schemas.microsoft.com/office/drawing/2014/main" id="{E99588F7-062E-CB4C-655D-44300457033D}"/>
               </a:ext>
             </a:extLst>
           </p:cNvPr>
@@ -3489,18 +3256,18 @@
         </p:nvGrpSpPr>
         <p:grpSpPr>
           <a:xfrm>
-            <a:off x="10503877" y="4006486"/>
-            <a:ext cx="10186493" cy="6510696"/>
-            <a:chOff x="10503877" y="4006486"/>
-            <a:chExt cx="10186493" cy="6510696"/>
+            <a:off x="422115" y="20656061"/>
+            <a:ext cx="20626880" cy="7094398"/>
+            <a:chOff x="693255" y="19051859"/>
+            <a:chExt cx="19997114" cy="8182785"/>
           </a:xfrm>
         </p:grpSpPr>
         <p:sp>
           <p:nvSpPr>
-            <p:cNvPr id="10" name="TextBox 9">
+            <p:cNvPr id="12" name="TextBox 11">
               <a:extLst>
                 <a:ext uri="{FF2B5EF4-FFF2-40B4-BE49-F238E27FC236}">
-                  <a16:creationId xmlns:a16="http://schemas.microsoft.com/office/drawing/2014/main" id="{0F1B1920-6667-A0E3-FB42-A9F282C7865A}"/>
+                  <a16:creationId xmlns:a16="http://schemas.microsoft.com/office/drawing/2014/main" id="{5F7ADA20-BAB6-6E7F-17BB-882BF96EEBDD}"/>
                 </a:ext>
               </a:extLst>
             </p:cNvPr>
@@ -3509,8 +3276,8 @@
           </p:nvSpPr>
           <p:spPr>
             <a:xfrm>
-              <a:off x="10503878" y="4006486"/>
-              <a:ext cx="10186492" cy="6510696"/>
+              <a:off x="693255" y="19051859"/>
+              <a:ext cx="19997114" cy="8182785"/>
             </a:xfrm>
             <a:prstGeom prst="roundRect">
               <a:avLst/>
@@ -3536,10 +3303,10 @@
         </p:sp>
         <p:sp>
           <p:nvSpPr>
-            <p:cNvPr id="2" name="Rectangle: Top Corners Rounded 1">
+            <p:cNvPr id="24" name="Rectangle: Top Corners Rounded 23">
               <a:extLst>
                 <a:ext uri="{FF2B5EF4-FFF2-40B4-BE49-F238E27FC236}">
-                  <a16:creationId xmlns:a16="http://schemas.microsoft.com/office/drawing/2014/main" id="{30F83BC8-84E3-1453-C408-D0D8C1FB4BE1}"/>
+                  <a16:creationId xmlns:a16="http://schemas.microsoft.com/office/drawing/2014/main" id="{A0C196ED-0F01-28DC-4022-F460723A87BB}"/>
                 </a:ext>
               </a:extLst>
             </p:cNvPr>
@@ -3548,8 +3315,8 @@
           </p:nvSpPr>
           <p:spPr>
             <a:xfrm>
-              <a:off x="10503877" y="4006486"/>
-              <a:ext cx="10186492" cy="1022714"/>
+              <a:off x="693256" y="19051859"/>
+              <a:ext cx="19997113" cy="1247714"/>
             </a:xfrm>
             <a:prstGeom prst="round2SameRect">
               <a:avLst/>
@@ -3584,16 +3351,693 @@
                   <a:latin typeface="Source Sans Pro Black" panose="020F0502020204030204" pitchFamily="34" charset="0"/>
                   <a:ea typeface="Source Sans Pro Black" panose="020F0502020204030204" pitchFamily="34" charset="0"/>
                 </a:rPr>
-                <a:t>Aims </a:t>
+                <a:t>Results and Conclusion</a:t>
+              </a:r>
+              <a:endParaRPr lang="en-GB" sz="4000" dirty="0">
+                <a:latin typeface="Source Sans Pro Black" panose="020F0502020204030204" pitchFamily="34" charset="0"/>
+              </a:endParaRPr>
+            </a:p>
+          </p:txBody>
+        </p:sp>
+      </p:grpSp>
+      <p:grpSp>
+        <p:nvGrpSpPr>
+          <p:cNvPr id="8" name="Group 7">
+            <a:extLst>
+              <a:ext uri="{FF2B5EF4-FFF2-40B4-BE49-F238E27FC236}">
+                <a16:creationId xmlns:a16="http://schemas.microsoft.com/office/drawing/2014/main" id="{6A2ED68F-F9FC-E4EF-62DA-257CC9AA76EF}"/>
+              </a:ext>
+            </a:extLst>
+          </p:cNvPr>
+          <p:cNvGrpSpPr/>
+          <p:nvPr/>
+        </p:nvGrpSpPr>
+        <p:grpSpPr>
+          <a:xfrm>
+            <a:off x="10506232" y="3040569"/>
+            <a:ext cx="10450401" cy="4897062"/>
+            <a:chOff x="10503877" y="4006486"/>
+            <a:chExt cx="10186493" cy="6510696"/>
+          </a:xfrm>
+        </p:grpSpPr>
+        <p:grpSp>
+          <p:nvGrpSpPr>
+            <p:cNvPr id="3" name="Group 2">
+              <a:extLst>
+                <a:ext uri="{FF2B5EF4-FFF2-40B4-BE49-F238E27FC236}">
+                  <a16:creationId xmlns:a16="http://schemas.microsoft.com/office/drawing/2014/main" id="{15284BD6-DD07-071F-83B7-F71BFC2DC062}"/>
+                </a:ext>
+              </a:extLst>
+            </p:cNvPr>
+            <p:cNvGrpSpPr/>
+            <p:nvPr/>
+          </p:nvGrpSpPr>
+          <p:grpSpPr>
+            <a:xfrm>
+              <a:off x="10503877" y="4006486"/>
+              <a:ext cx="10186493" cy="6510696"/>
+              <a:chOff x="10503877" y="4006486"/>
+              <a:chExt cx="10186493" cy="6510696"/>
+            </a:xfrm>
+          </p:grpSpPr>
+          <p:sp>
+            <p:nvSpPr>
+              <p:cNvPr id="10" name="TextBox 9">
+                <a:extLst>
+                  <a:ext uri="{FF2B5EF4-FFF2-40B4-BE49-F238E27FC236}">
+                    <a16:creationId xmlns:a16="http://schemas.microsoft.com/office/drawing/2014/main" id="{0F1B1920-6667-A0E3-FB42-A9F282C7865A}"/>
+                  </a:ext>
+                </a:extLst>
+              </p:cNvPr>
+              <p:cNvSpPr txBox="1"/>
+              <p:nvPr/>
+            </p:nvSpPr>
+            <p:spPr>
+              <a:xfrm>
+                <a:off x="10503878" y="4006486"/>
+                <a:ext cx="10186492" cy="6510696"/>
+              </a:xfrm>
+              <a:prstGeom prst="roundRect">
+                <a:avLst/>
+              </a:prstGeom>
+              <a:solidFill>
+                <a:schemeClr val="bg1"/>
+              </a:solidFill>
+              <a:ln>
+                <a:solidFill>
+                  <a:schemeClr val="accent1"/>
+                </a:solidFill>
+              </a:ln>
+            </p:spPr>
+            <p:txBody>
+              <a:bodyPr wrap="square" rtlCol="0">
+                <a:noAutofit/>
+              </a:bodyPr>
+              <a:lstStyle/>
+              <a:p>
+                <a:endParaRPr lang="en-GB" dirty="0"/>
+              </a:p>
+            </p:txBody>
+          </p:sp>
+          <p:sp>
+            <p:nvSpPr>
+              <p:cNvPr id="2" name="Rectangle: Top Corners Rounded 1">
+                <a:extLst>
+                  <a:ext uri="{FF2B5EF4-FFF2-40B4-BE49-F238E27FC236}">
+                    <a16:creationId xmlns:a16="http://schemas.microsoft.com/office/drawing/2014/main" id="{30F83BC8-84E3-1453-C408-D0D8C1FB4BE1}"/>
+                  </a:ext>
+                </a:extLst>
+              </p:cNvPr>
+              <p:cNvSpPr/>
+              <p:nvPr/>
+            </p:nvSpPr>
+            <p:spPr>
+              <a:xfrm>
+                <a:off x="10503877" y="4006486"/>
+                <a:ext cx="10186492" cy="1022714"/>
+              </a:xfrm>
+              <a:prstGeom prst="round2SameRect">
+                <a:avLst/>
+              </a:prstGeom>
+              <a:solidFill>
+                <a:srgbClr val="07453F"/>
+              </a:solidFill>
+            </p:spPr>
+            <p:style>
+              <a:lnRef idx="2">
+                <a:schemeClr val="accent1">
+                  <a:shade val="15000"/>
+                </a:schemeClr>
+              </a:lnRef>
+              <a:fillRef idx="1">
+                <a:schemeClr val="accent1"/>
+              </a:fillRef>
+              <a:effectRef idx="0">
+                <a:schemeClr val="accent1"/>
+              </a:effectRef>
+              <a:fontRef idx="minor">
+                <a:schemeClr val="lt1"/>
+              </a:fontRef>
+            </p:style>
+            <p:txBody>
+              <a:bodyPr rtlCol="0" anchor="ctr"/>
+              <a:lstStyle/>
+              <a:p>
+                <a:pPr algn="ctr"/>
+                <a:r>
+                  <a:rPr lang="en-GB" sz="4000" dirty="0">
+                    <a:latin typeface="Source Sans Pro Black" panose="020F0502020204030204" pitchFamily="34" charset="0"/>
+                    <a:ea typeface="Source Sans Pro Black" panose="020F0502020204030204" pitchFamily="34" charset="0"/>
+                  </a:rPr>
+                  <a:t>Aims </a:t>
+                </a:r>
+                <a:r>
+                  <a:rPr lang="en-GB" sz="4000">
+                    <a:latin typeface="Source Sans Pro Black" panose="020F0502020204030204" pitchFamily="34" charset="0"/>
+                    <a:ea typeface="Source Sans Pro Black" panose="020F0502020204030204" pitchFamily="34" charset="0"/>
+                  </a:rPr>
+                  <a:t>and Objectives</a:t>
+                </a:r>
+                <a:endParaRPr lang="en-GB" sz="3200" dirty="0">
+                  <a:latin typeface="Source Sans Pro Black" panose="020F0502020204030204" pitchFamily="34" charset="0"/>
+                </a:endParaRPr>
+              </a:p>
+            </p:txBody>
+          </p:sp>
+        </p:grpSp>
+        <p:sp>
+          <p:nvSpPr>
+            <p:cNvPr id="4" name="TextBox 3">
+              <a:extLst>
+                <a:ext uri="{FF2B5EF4-FFF2-40B4-BE49-F238E27FC236}">
+                  <a16:creationId xmlns:a16="http://schemas.microsoft.com/office/drawing/2014/main" id="{FE12A528-2AA1-F28F-AFE0-B615E1F67B6F}"/>
+                </a:ext>
+              </a:extLst>
+            </p:cNvPr>
+            <p:cNvSpPr txBox="1"/>
+            <p:nvPr/>
+          </p:nvSpPr>
+          <p:spPr>
+            <a:xfrm>
+              <a:off x="10691812" y="5196840"/>
+              <a:ext cx="9748546" cy="4989475"/>
+            </a:xfrm>
+            <a:prstGeom prst="rect">
+              <a:avLst/>
+            </a:prstGeom>
+            <a:noFill/>
+          </p:spPr>
+          <p:txBody>
+            <a:bodyPr wrap="square" rtlCol="0">
+              <a:noAutofit/>
+            </a:bodyPr>
+            <a:lstStyle/>
+            <a:p>
+              <a:pPr marL="457200" indent="-457200">
+                <a:buFont typeface="Wingdings" panose="05000000000000000000" pitchFamily="2" charset="2"/>
+                <a:buChar char="Ø"/>
+              </a:pPr>
+              <a:r>
+                <a:rPr lang="en-GB" sz="2800" dirty="0"/>
+                <a:t>Create and implement a </a:t>
               </a:r>
               <a:r>
-                <a:rPr lang="en-GB" sz="4000">
+                <a:rPr lang="en-GB" sz="2800" dirty="0" err="1"/>
+                <a:t>hyperheuristic</a:t>
+              </a:r>
+              <a:r>
+                <a:rPr lang="en-GB" sz="2800" dirty="0"/>
+                <a:t> that operates on the problem domains in Hyflex</a:t>
+              </a:r>
+            </a:p>
+            <a:p>
+              <a:pPr marL="457200" indent="-457200">
+                <a:buFont typeface="Wingdings" panose="05000000000000000000" pitchFamily="2" charset="2"/>
+                <a:buChar char="Ø"/>
+              </a:pPr>
+              <a:r>
+                <a:rPr lang="en-GB" sz="2800" dirty="0"/>
+                <a:t>Attach a Python-Java Gateway that runs Hyflex </a:t>
+              </a:r>
+              <a:r>
+                <a:rPr lang="en-GB" sz="2800" dirty="0" err="1"/>
+                <a:t>hyperheuristics</a:t>
+              </a:r>
+              <a:r>
+                <a:rPr lang="en-GB" sz="2800" dirty="0"/>
+                <a:t> on the problem domains to visually compare results</a:t>
+              </a:r>
+            </a:p>
+            <a:p>
+              <a:pPr marL="457200" indent="-457200">
+                <a:buFont typeface="Wingdings" panose="05000000000000000000" pitchFamily="2" charset="2"/>
+                <a:buChar char="Ø"/>
+              </a:pPr>
+              <a:r>
+                <a:rPr lang="en-GB" sz="2800" dirty="0"/>
+                <a:t>Attempt to see if pre-training a </a:t>
+              </a:r>
+              <a:r>
+                <a:rPr lang="en-GB" sz="2800" dirty="0" err="1"/>
+                <a:t>hyperheuristic</a:t>
+              </a:r>
+              <a:r>
+                <a:rPr lang="en-GB" sz="2800" dirty="0"/>
+                <a:t> is achievable</a:t>
+              </a:r>
+            </a:p>
+            <a:p>
+              <a:pPr marL="457200" indent="-457200">
+                <a:buFont typeface="Wingdings" panose="05000000000000000000" pitchFamily="2" charset="2"/>
+                <a:buChar char="§"/>
+              </a:pPr>
+              <a:endParaRPr lang="en-GB" sz="2800" dirty="0"/>
+            </a:p>
+          </p:txBody>
+        </p:sp>
+      </p:grpSp>
+      <p:grpSp>
+        <p:nvGrpSpPr>
+          <p:cNvPr id="13" name="Group 12">
+            <a:extLst>
+              <a:ext uri="{FF2B5EF4-FFF2-40B4-BE49-F238E27FC236}">
+                <a16:creationId xmlns:a16="http://schemas.microsoft.com/office/drawing/2014/main" id="{E8911E45-2258-2910-9FF3-6B0789D15C7D}"/>
+              </a:ext>
+            </a:extLst>
+          </p:cNvPr>
+          <p:cNvGrpSpPr/>
+          <p:nvPr/>
+        </p:nvGrpSpPr>
+        <p:grpSpPr>
+          <a:xfrm>
+            <a:off x="422115" y="3040569"/>
+            <a:ext cx="9827523" cy="4897062"/>
+            <a:chOff x="570592" y="4006486"/>
+            <a:chExt cx="9807848" cy="6510696"/>
+          </a:xfrm>
+        </p:grpSpPr>
+        <p:grpSp>
+          <p:nvGrpSpPr>
+            <p:cNvPr id="22" name="Group 21">
+              <a:extLst>
+                <a:ext uri="{FF2B5EF4-FFF2-40B4-BE49-F238E27FC236}">
+                  <a16:creationId xmlns:a16="http://schemas.microsoft.com/office/drawing/2014/main" id="{6DB9F096-8FB2-0F13-21D3-A0A3D8856AA0}"/>
+                </a:ext>
+              </a:extLst>
+            </p:cNvPr>
+            <p:cNvGrpSpPr/>
+            <p:nvPr/>
+          </p:nvGrpSpPr>
+          <p:grpSpPr>
+            <a:xfrm>
+              <a:off x="570592" y="4006486"/>
+              <a:ext cx="9807848" cy="6510696"/>
+              <a:chOff x="570592" y="4006486"/>
+              <a:chExt cx="9807848" cy="6510696"/>
+            </a:xfrm>
+          </p:grpSpPr>
+          <p:sp>
+            <p:nvSpPr>
+              <p:cNvPr id="9" name="TextBox 8">
+                <a:extLst>
+                  <a:ext uri="{FF2B5EF4-FFF2-40B4-BE49-F238E27FC236}">
+                    <a16:creationId xmlns:a16="http://schemas.microsoft.com/office/drawing/2014/main" id="{BD174AE8-AF0B-34A4-7717-7077F0ACB2D9}"/>
+                  </a:ext>
+                </a:extLst>
+              </p:cNvPr>
+              <p:cNvSpPr txBox="1"/>
+              <p:nvPr/>
+            </p:nvSpPr>
+            <p:spPr>
+              <a:xfrm>
+                <a:off x="570592" y="4006486"/>
+                <a:ext cx="9807847" cy="6510696"/>
+              </a:xfrm>
+              <a:prstGeom prst="roundRect">
+                <a:avLst/>
+              </a:prstGeom>
+              <a:solidFill>
+                <a:schemeClr val="bg1"/>
+              </a:solidFill>
+              <a:ln>
+                <a:solidFill>
+                  <a:schemeClr val="accent1"/>
+                </a:solidFill>
+              </a:ln>
+            </p:spPr>
+            <p:txBody>
+              <a:bodyPr wrap="square" rtlCol="0">
+                <a:noAutofit/>
+              </a:bodyPr>
+              <a:lstStyle/>
+              <a:p>
+                <a:endParaRPr lang="en-GB" dirty="0"/>
+              </a:p>
+            </p:txBody>
+          </p:sp>
+          <p:sp>
+            <p:nvSpPr>
+              <p:cNvPr id="21" name="Rectangle: Top Corners Rounded 20">
+                <a:extLst>
+                  <a:ext uri="{FF2B5EF4-FFF2-40B4-BE49-F238E27FC236}">
+                    <a16:creationId xmlns:a16="http://schemas.microsoft.com/office/drawing/2014/main" id="{CEA43005-15C9-DD71-26B3-326FF054B01A}"/>
+                  </a:ext>
+                </a:extLst>
+              </p:cNvPr>
+              <p:cNvSpPr/>
+              <p:nvPr/>
+            </p:nvSpPr>
+            <p:spPr>
+              <a:xfrm>
+                <a:off x="570594" y="4006486"/>
+                <a:ext cx="9807846" cy="1022714"/>
+              </a:xfrm>
+              <a:prstGeom prst="round2SameRect">
+                <a:avLst/>
+              </a:prstGeom>
+              <a:solidFill>
+                <a:srgbClr val="07453F"/>
+              </a:solidFill>
+            </p:spPr>
+            <p:style>
+              <a:lnRef idx="2">
+                <a:schemeClr val="accent1">
+                  <a:shade val="15000"/>
+                </a:schemeClr>
+              </a:lnRef>
+              <a:fillRef idx="1">
+                <a:schemeClr val="accent1"/>
+              </a:fillRef>
+              <a:effectRef idx="0">
+                <a:schemeClr val="accent1"/>
+              </a:effectRef>
+              <a:fontRef idx="minor">
+                <a:schemeClr val="lt1"/>
+              </a:fontRef>
+            </p:style>
+            <p:txBody>
+              <a:bodyPr rtlCol="0" anchor="ctr"/>
+              <a:lstStyle/>
+              <a:p>
+                <a:pPr algn="ctr"/>
+                <a:r>
+                  <a:rPr lang="en-GB" sz="4000" dirty="0">
+                    <a:latin typeface="Source Sans Pro Black" panose="020F0502020204030204" pitchFamily="34" charset="0"/>
+                    <a:ea typeface="Source Sans Pro Black" panose="020F0502020204030204" pitchFamily="34" charset="0"/>
+                  </a:rPr>
+                  <a:t>Motivation</a:t>
+                </a:r>
+                <a:endParaRPr lang="en-GB" sz="3200" dirty="0">
+                  <a:latin typeface="Source Sans Pro Black" panose="020F0502020204030204" pitchFamily="34" charset="0"/>
+                </a:endParaRPr>
+              </a:p>
+            </p:txBody>
+          </p:sp>
+        </p:grpSp>
+        <p:sp>
+          <p:nvSpPr>
+            <p:cNvPr id="5" name="TextBox 4">
+              <a:extLst>
+                <a:ext uri="{FF2B5EF4-FFF2-40B4-BE49-F238E27FC236}">
+                  <a16:creationId xmlns:a16="http://schemas.microsoft.com/office/drawing/2014/main" id="{C9D3E116-DEFF-2225-53ED-4B47AB7C8B61}"/>
+                </a:ext>
+              </a:extLst>
+            </p:cNvPr>
+            <p:cNvSpPr txBox="1"/>
+            <p:nvPr/>
+          </p:nvSpPr>
+          <p:spPr>
+            <a:xfrm>
+              <a:off x="822960" y="5196840"/>
+              <a:ext cx="9281160" cy="4989475"/>
+            </a:xfrm>
+            <a:prstGeom prst="rect">
+              <a:avLst/>
+            </a:prstGeom>
+            <a:noFill/>
+          </p:spPr>
+          <p:txBody>
+            <a:bodyPr wrap="square" rtlCol="0">
+              <a:noAutofit/>
+            </a:bodyPr>
+            <a:lstStyle/>
+            <a:p>
+              <a:pPr marL="457200" indent="-457200">
+                <a:buFont typeface="Wingdings" panose="05000000000000000000" pitchFamily="2" charset="2"/>
+                <a:buChar char="§"/>
+              </a:pPr>
+              <a:r>
+                <a:rPr lang="en-GB" sz="2800" b="1" dirty="0"/>
+                <a:t>Transfer Learning Between Problem Instances: </a:t>
+              </a:r>
+              <a:r>
+                <a:rPr lang="en-GB" sz="2800" dirty="0"/>
+                <a:t>Allows hyper-heuristic exploit previously learning heuristic performance patterns</a:t>
+              </a:r>
+              <a:endParaRPr lang="en-GB" sz="2800" b="1" dirty="0"/>
+            </a:p>
+            <a:p>
+              <a:pPr marL="457200" indent="-457200">
+                <a:buFont typeface="Wingdings" panose="05000000000000000000" pitchFamily="2" charset="2"/>
+                <a:buChar char="§"/>
+              </a:pPr>
+              <a:r>
+                <a:rPr lang="en-GB" sz="2800" b="1" dirty="0"/>
+                <a:t>Improving Early-Stage Solution Quality: </a:t>
+              </a:r>
+              <a:r>
+                <a:rPr lang="en-GB" sz="2800" dirty="0"/>
+                <a:t>Helps hyper-heuristics prioritise heuristics that work well with similar </a:t>
+              </a:r>
+            </a:p>
+            <a:p>
+              <a:pPr marL="457200" indent="-457200">
+                <a:buFont typeface="Wingdings" panose="05000000000000000000" pitchFamily="2" charset="2"/>
+                <a:buChar char="§"/>
+              </a:pPr>
+              <a:r>
+                <a:rPr lang="en-GB" sz="2800" b="1" dirty="0"/>
+                <a:t>Stabilise Heuristic Selection Behaviour: </a:t>
+              </a:r>
+              <a:r>
+                <a:rPr lang="en-GB" sz="2800" dirty="0"/>
+                <a:t>Heuristic Selection is highly stochastic. Learns consistent patterns across multiple training runs</a:t>
+              </a:r>
+              <a:endParaRPr lang="en-GB" sz="2800" b="1" dirty="0"/>
+            </a:p>
+          </p:txBody>
+        </p:sp>
+      </p:grpSp>
+      <p:grpSp>
+        <p:nvGrpSpPr>
+          <p:cNvPr id="18" name="Group 17">
+            <a:extLst>
+              <a:ext uri="{FF2B5EF4-FFF2-40B4-BE49-F238E27FC236}">
+                <a16:creationId xmlns:a16="http://schemas.microsoft.com/office/drawing/2014/main" id="{88492880-B1A1-A91A-73A5-77FAE74825AE}"/>
+              </a:ext>
+            </a:extLst>
+          </p:cNvPr>
+          <p:cNvGrpSpPr/>
+          <p:nvPr/>
+        </p:nvGrpSpPr>
+        <p:grpSpPr>
+          <a:xfrm>
+            <a:off x="422114" y="28018154"/>
+            <a:ext cx="20534518" cy="1866999"/>
+            <a:chOff x="693255" y="27437524"/>
+            <a:chExt cx="19997113" cy="2447629"/>
+          </a:xfrm>
+        </p:grpSpPr>
+        <p:sp>
+          <p:nvSpPr>
+            <p:cNvPr id="20" name="TextBox 19">
+              <a:extLst>
+                <a:ext uri="{FF2B5EF4-FFF2-40B4-BE49-F238E27FC236}">
+                  <a16:creationId xmlns:a16="http://schemas.microsoft.com/office/drawing/2014/main" id="{1E03E00E-8E28-7868-2FEA-6F77FB579AF7}"/>
+                </a:ext>
+              </a:extLst>
+            </p:cNvPr>
+            <p:cNvSpPr txBox="1"/>
+            <p:nvPr/>
+          </p:nvSpPr>
+          <p:spPr>
+            <a:xfrm>
+              <a:off x="693255" y="27437525"/>
+              <a:ext cx="19997113" cy="2447628"/>
+            </a:xfrm>
+            <a:prstGeom prst="roundRect">
+              <a:avLst/>
+            </a:prstGeom>
+            <a:solidFill>
+              <a:schemeClr val="bg1"/>
+            </a:solidFill>
+            <a:ln>
+              <a:solidFill>
+                <a:schemeClr val="accent1"/>
+              </a:solidFill>
+            </a:ln>
+          </p:spPr>
+          <p:txBody>
+            <a:bodyPr wrap="square" rtlCol="0">
+              <a:noAutofit/>
+            </a:bodyPr>
+            <a:lstStyle/>
+            <a:p>
+              <a:endParaRPr lang="en-GB" dirty="0"/>
+            </a:p>
+          </p:txBody>
+        </p:sp>
+        <p:sp>
+          <p:nvSpPr>
+            <p:cNvPr id="7" name="Rectangle: Top Corners Rounded 6">
+              <a:extLst>
+                <a:ext uri="{FF2B5EF4-FFF2-40B4-BE49-F238E27FC236}">
+                  <a16:creationId xmlns:a16="http://schemas.microsoft.com/office/drawing/2014/main" id="{4616C8A7-7E1F-F1BD-585B-616CD003EC8E}"/>
+                </a:ext>
+              </a:extLst>
+            </p:cNvPr>
+            <p:cNvSpPr/>
+            <p:nvPr/>
+          </p:nvSpPr>
+          <p:spPr>
+            <a:xfrm>
+              <a:off x="693255" y="27437524"/>
+              <a:ext cx="19997113" cy="799183"/>
+            </a:xfrm>
+            <a:prstGeom prst="round2SameRect">
+              <a:avLst/>
+            </a:prstGeom>
+            <a:solidFill>
+              <a:srgbClr val="07453F"/>
+            </a:solidFill>
+          </p:spPr>
+          <p:style>
+            <a:lnRef idx="2">
+              <a:schemeClr val="accent1">
+                <a:shade val="15000"/>
+              </a:schemeClr>
+            </a:lnRef>
+            <a:fillRef idx="1">
+              <a:schemeClr val="accent1"/>
+            </a:fillRef>
+            <a:effectRef idx="0">
+              <a:schemeClr val="accent1"/>
+            </a:effectRef>
+            <a:fontRef idx="minor">
+              <a:schemeClr val="lt1"/>
+            </a:fontRef>
+          </p:style>
+          <p:txBody>
+            <a:bodyPr rtlCol="0" anchor="ctr"/>
+            <a:lstStyle/>
+            <a:p>
+              <a:pPr algn="ctr"/>
+              <a:r>
+                <a:rPr lang="en-GB" sz="4000" dirty="0">
                   <a:latin typeface="Source Sans Pro Black" panose="020F0502020204030204" pitchFamily="34" charset="0"/>
                   <a:ea typeface="Source Sans Pro Black" panose="020F0502020204030204" pitchFamily="34" charset="0"/>
                 </a:rPr>
-                <a:t>and Objectives</a:t>
+                <a:t>References</a:t>
               </a:r>
-              <a:endParaRPr lang="en-GB" sz="3200" dirty="0">
+              <a:endParaRPr lang="en-GB" sz="4000" dirty="0">
+                <a:latin typeface="Source Sans Pro Black" panose="020F0502020204030204" pitchFamily="34" charset="0"/>
+              </a:endParaRPr>
+            </a:p>
+          </p:txBody>
+        </p:sp>
+      </p:grpSp>
+      <p:grpSp>
+        <p:nvGrpSpPr>
+          <p:cNvPr id="19" name="Group 18">
+            <a:extLst>
+              <a:ext uri="{FF2B5EF4-FFF2-40B4-BE49-F238E27FC236}">
+                <a16:creationId xmlns:a16="http://schemas.microsoft.com/office/drawing/2014/main" id="{ABE5F356-D971-5F9D-6770-42051A4A760A}"/>
+              </a:ext>
+            </a:extLst>
+          </p:cNvPr>
+          <p:cNvGrpSpPr/>
+          <p:nvPr/>
+        </p:nvGrpSpPr>
+        <p:grpSpPr>
+          <a:xfrm>
+            <a:off x="422116" y="15698365"/>
+            <a:ext cx="20626882" cy="4690000"/>
+            <a:chOff x="693255" y="19051859"/>
+            <a:chExt cx="19997114" cy="8182785"/>
+          </a:xfrm>
+        </p:grpSpPr>
+        <p:sp>
+          <p:nvSpPr>
+            <p:cNvPr id="25" name="TextBox 24">
+              <a:extLst>
+                <a:ext uri="{FF2B5EF4-FFF2-40B4-BE49-F238E27FC236}">
+                  <a16:creationId xmlns:a16="http://schemas.microsoft.com/office/drawing/2014/main" id="{6B7C1514-7254-36FB-A962-8706DBB74D74}"/>
+                </a:ext>
+              </a:extLst>
+            </p:cNvPr>
+            <p:cNvSpPr txBox="1"/>
+            <p:nvPr/>
+          </p:nvSpPr>
+          <p:spPr>
+            <a:xfrm>
+              <a:off x="693255" y="19051859"/>
+              <a:ext cx="19997114" cy="8182785"/>
+            </a:xfrm>
+            <a:prstGeom prst="roundRect">
+              <a:avLst/>
+            </a:prstGeom>
+            <a:solidFill>
+              <a:schemeClr val="bg1"/>
+            </a:solidFill>
+            <a:ln>
+              <a:solidFill>
+                <a:schemeClr val="accent1"/>
+              </a:solidFill>
+            </a:ln>
+          </p:spPr>
+          <p:txBody>
+            <a:bodyPr wrap="square" rtlCol="0">
+              <a:noAutofit/>
+            </a:bodyPr>
+            <a:lstStyle/>
+            <a:p>
+              <a:endParaRPr lang="en-GB" dirty="0"/>
+            </a:p>
+          </p:txBody>
+        </p:sp>
+        <p:sp>
+          <p:nvSpPr>
+            <p:cNvPr id="26" name="Rectangle: Top Corners Rounded 25">
+              <a:extLst>
+                <a:ext uri="{FF2B5EF4-FFF2-40B4-BE49-F238E27FC236}">
+                  <a16:creationId xmlns:a16="http://schemas.microsoft.com/office/drawing/2014/main" id="{3273D125-2609-3E9C-6D92-64B2BE24480C}"/>
+                </a:ext>
+              </a:extLst>
+            </p:cNvPr>
+            <p:cNvSpPr/>
+            <p:nvPr/>
+          </p:nvSpPr>
+          <p:spPr>
+            <a:xfrm>
+              <a:off x="693256" y="19051859"/>
+              <a:ext cx="19997113" cy="1247714"/>
+            </a:xfrm>
+            <a:prstGeom prst="round2SameRect">
+              <a:avLst/>
+            </a:prstGeom>
+            <a:solidFill>
+              <a:srgbClr val="07453F"/>
+            </a:solidFill>
+          </p:spPr>
+          <p:style>
+            <a:lnRef idx="2">
+              <a:schemeClr val="accent1">
+                <a:shade val="15000"/>
+              </a:schemeClr>
+            </a:lnRef>
+            <a:fillRef idx="1">
+              <a:schemeClr val="accent1"/>
+            </a:fillRef>
+            <a:effectRef idx="0">
+              <a:schemeClr val="accent1"/>
+            </a:effectRef>
+            <a:fontRef idx="minor">
+              <a:schemeClr val="lt1"/>
+            </a:fontRef>
+          </p:style>
+          <p:txBody>
+            <a:bodyPr rtlCol="0" anchor="ctr"/>
+            <a:lstStyle/>
+            <a:p>
+              <a:pPr algn="ctr"/>
+              <a:r>
+                <a:rPr lang="en-GB" sz="4000" dirty="0">
+                  <a:latin typeface="Source Sans Pro Black" panose="020F0502020204030204" pitchFamily="34" charset="0"/>
+                  <a:ea typeface="Source Sans Pro Black" panose="020F0502020204030204" pitchFamily="34" charset="0"/>
+                </a:rPr>
+                <a:t>Implementation</a:t>
+              </a:r>
+              <a:endParaRPr lang="en-GB" sz="4000" dirty="0">
                 <a:latin typeface="Source Sans Pro Black" panose="020F0502020204030204" pitchFamily="34" charset="0"/>
               </a:endParaRPr>
             </a:p>

</xml_diff>

<commit_message>
Reduced number of Q-Table states, adjusted Epsilon values, normalised choice function scores so it does not overwhelm q-values, helping prioritisation of q-values. Furthermore, updated log book
</commit_message>
<xml_diff>
--- a/docs/Project A1 Poster.pptx
+++ b/docs/Project A1 Poster.pptx
@@ -243,7 +243,7 @@
           <a:p>
             <a:fld id="{FA5823AB-6602-42D2-BF55-2A857A74F7FB}" type="datetimeFigureOut">
               <a:rPr lang="en-GB" smtClean="0"/>
-              <a:t>15/03/2026</a:t>
+              <a:t>16/03/2026</a:t>
             </a:fld>
             <a:endParaRPr lang="en-GB"/>
           </a:p>
@@ -413,7 +413,7 @@
           <a:p>
             <a:fld id="{FA5823AB-6602-42D2-BF55-2A857A74F7FB}" type="datetimeFigureOut">
               <a:rPr lang="en-GB" smtClean="0"/>
-              <a:t>15/03/2026</a:t>
+              <a:t>16/03/2026</a:t>
             </a:fld>
             <a:endParaRPr lang="en-GB"/>
           </a:p>
@@ -593,7 +593,7 @@
           <a:p>
             <a:fld id="{FA5823AB-6602-42D2-BF55-2A857A74F7FB}" type="datetimeFigureOut">
               <a:rPr lang="en-GB" smtClean="0"/>
-              <a:t>15/03/2026</a:t>
+              <a:t>16/03/2026</a:t>
             </a:fld>
             <a:endParaRPr lang="en-GB"/>
           </a:p>
@@ -763,7 +763,7 @@
           <a:p>
             <a:fld id="{FA5823AB-6602-42D2-BF55-2A857A74F7FB}" type="datetimeFigureOut">
               <a:rPr lang="en-GB" smtClean="0"/>
-              <a:t>15/03/2026</a:t>
+              <a:t>16/03/2026</a:t>
             </a:fld>
             <a:endParaRPr lang="en-GB"/>
           </a:p>
@@ -1009,7 +1009,7 @@
           <a:p>
             <a:fld id="{FA5823AB-6602-42D2-BF55-2A857A74F7FB}" type="datetimeFigureOut">
               <a:rPr lang="en-GB" smtClean="0"/>
-              <a:t>15/03/2026</a:t>
+              <a:t>16/03/2026</a:t>
             </a:fld>
             <a:endParaRPr lang="en-GB"/>
           </a:p>
@@ -1543,7 +1543,7 @@
           <a:p>
             <a:fld id="{FA5823AB-6602-42D2-BF55-2A857A74F7FB}" type="datetimeFigureOut">
               <a:rPr lang="en-GB" smtClean="0"/>
-              <a:t>15/03/2026</a:t>
+              <a:t>16/03/2026</a:t>
             </a:fld>
             <a:endParaRPr lang="en-GB"/>
           </a:p>
@@ -1661,7 +1661,7 @@
           <a:p>
             <a:fld id="{FA5823AB-6602-42D2-BF55-2A857A74F7FB}" type="datetimeFigureOut">
               <a:rPr lang="en-GB" smtClean="0"/>
-              <a:t>15/03/2026</a:t>
+              <a:t>16/03/2026</a:t>
             </a:fld>
             <a:endParaRPr lang="en-GB"/>
           </a:p>
@@ -1756,7 +1756,7 @@
           <a:p>
             <a:fld id="{FA5823AB-6602-42D2-BF55-2A857A74F7FB}" type="datetimeFigureOut">
               <a:rPr lang="en-GB" smtClean="0"/>
-              <a:t>15/03/2026</a:t>
+              <a:t>16/03/2026</a:t>
             </a:fld>
             <a:endParaRPr lang="en-GB"/>
           </a:p>
@@ -2033,7 +2033,7 @@
           <a:p>
             <a:fld id="{FA5823AB-6602-42D2-BF55-2A857A74F7FB}" type="datetimeFigureOut">
               <a:rPr lang="en-GB" smtClean="0"/>
-              <a:t>15/03/2026</a:t>
+              <a:t>16/03/2026</a:t>
             </a:fld>
             <a:endParaRPr lang="en-GB"/>
           </a:p>
@@ -2290,7 +2290,7 @@
           <a:p>
             <a:fld id="{FA5823AB-6602-42D2-BF55-2A857A74F7FB}" type="datetimeFigureOut">
               <a:rPr lang="en-GB" smtClean="0"/>
-              <a:t>15/03/2026</a:t>
+              <a:t>16/03/2026</a:t>
             </a:fld>
             <a:endParaRPr lang="en-GB"/>
           </a:p>
@@ -2503,7 +2503,7 @@
           <a:p>
             <a:fld id="{FA5823AB-6602-42D2-BF55-2A857A74F7FB}" type="datetimeFigureOut">
               <a:rPr lang="en-GB" smtClean="0"/>
-              <a:t>15/03/2026</a:t>
+              <a:t>16/03/2026</a:t>
             </a:fld>
             <a:endParaRPr lang="en-GB"/>
           </a:p>
@@ -3138,10 +3138,10 @@
         </p:nvGrpSpPr>
         <p:grpSpPr>
           <a:xfrm>
-            <a:off x="422116" y="8143714"/>
-            <a:ext cx="20534520" cy="7357422"/>
-            <a:chOff x="570591" y="10666194"/>
-            <a:chExt cx="19997116" cy="8182785"/>
+            <a:off x="422116" y="7253603"/>
+            <a:ext cx="20534520" cy="8247533"/>
+            <a:chOff x="570591" y="10666193"/>
+            <a:chExt cx="19997116" cy="8182786"/>
           </a:xfrm>
         </p:grpSpPr>
         <p:sp>
@@ -3197,8 +3197,8 @@
           </p:nvSpPr>
           <p:spPr>
             <a:xfrm>
-              <a:off x="570591" y="10666194"/>
-              <a:ext cx="19997113" cy="1304393"/>
+              <a:off x="570591" y="10666193"/>
+              <a:ext cx="19997113" cy="1253050"/>
             </a:xfrm>
             <a:prstGeom prst="round2SameRect">
               <a:avLst/>
@@ -3256,8 +3256,8 @@
         </p:nvGrpSpPr>
         <p:grpSpPr>
           <a:xfrm>
-            <a:off x="422115" y="20656061"/>
-            <a:ext cx="20626880" cy="7094398"/>
+            <a:off x="422115" y="20851241"/>
+            <a:ext cx="20626880" cy="6899218"/>
             <a:chOff x="693255" y="19051859"/>
             <a:chExt cx="19997114" cy="8182785"/>
           </a:xfrm>
@@ -3375,7 +3375,7 @@
         <p:grpSpPr>
           <a:xfrm>
             <a:off x="10506232" y="3040569"/>
-            <a:ext cx="10450401" cy="4897062"/>
+            <a:ext cx="10450401" cy="4086944"/>
             <a:chOff x="10503877" y="4006486"/>
             <a:chExt cx="10186493" cy="6510696"/>
           </a:xfrm>
@@ -3538,15 +3538,15 @@
                 <a:buChar char="Ø"/>
               </a:pPr>
               <a:r>
-                <a:rPr lang="en-GB" sz="2800" dirty="0"/>
+                <a:rPr lang="en-GB" sz="2400" dirty="0"/>
                 <a:t>Create and implement a </a:t>
               </a:r>
               <a:r>
-                <a:rPr lang="en-GB" sz="2800" dirty="0" err="1"/>
+                <a:rPr lang="en-GB" sz="2400" dirty="0" err="1"/>
                 <a:t>hyperheuristic</a:t>
               </a:r>
               <a:r>
-                <a:rPr lang="en-GB" sz="2800" dirty="0"/>
+                <a:rPr lang="en-GB" sz="2400" dirty="0"/>
                 <a:t> that operates on the problem domains in Hyflex</a:t>
               </a:r>
             </a:p>
@@ -3556,15 +3556,15 @@
                 <a:buChar char="Ø"/>
               </a:pPr>
               <a:r>
-                <a:rPr lang="en-GB" sz="2800" dirty="0"/>
+                <a:rPr lang="en-GB" sz="2400" dirty="0"/>
                 <a:t>Attach a Python-Java Gateway that runs Hyflex </a:t>
               </a:r>
               <a:r>
-                <a:rPr lang="en-GB" sz="2800" dirty="0" err="1"/>
+                <a:rPr lang="en-GB" sz="2400" dirty="0" err="1"/>
                 <a:t>hyperheuristics</a:t>
               </a:r>
               <a:r>
-                <a:rPr lang="en-GB" sz="2800" dirty="0"/>
+                <a:rPr lang="en-GB" sz="2400" dirty="0"/>
                 <a:t> on the problem domains to visually compare results</a:t>
               </a:r>
             </a:p>
@@ -3574,15 +3574,15 @@
                 <a:buChar char="Ø"/>
               </a:pPr>
               <a:r>
-                <a:rPr lang="en-GB" sz="2800" dirty="0"/>
+                <a:rPr lang="en-GB" sz="2400" dirty="0"/>
                 <a:t>Attempt to see if pre-training a </a:t>
               </a:r>
               <a:r>
-                <a:rPr lang="en-GB" sz="2800" dirty="0" err="1"/>
+                <a:rPr lang="en-GB" sz="2400" dirty="0" err="1"/>
                 <a:t>hyperheuristic</a:t>
               </a:r>
               <a:r>
-                <a:rPr lang="en-GB" sz="2800" dirty="0"/>
+                <a:rPr lang="en-GB" sz="2400" dirty="0"/>
                 <a:t> is achievable</a:t>
               </a:r>
             </a:p>
@@ -3611,9 +3611,9 @@
         <p:grpSpPr>
           <a:xfrm>
             <a:off x="422115" y="3040569"/>
-            <a:ext cx="9827523" cy="4897062"/>
-            <a:chOff x="570592" y="4006486"/>
-            <a:chExt cx="9807848" cy="6510696"/>
+            <a:ext cx="9827523" cy="4086945"/>
+            <a:chOff x="570592" y="4006485"/>
+            <a:chExt cx="9807848" cy="5433637"/>
           </a:xfrm>
         </p:grpSpPr>
         <p:grpSp>
@@ -3630,10 +3630,10 @@
           </p:nvGrpSpPr>
           <p:grpSpPr>
             <a:xfrm>
-              <a:off x="570592" y="4006486"/>
-              <a:ext cx="9807848" cy="6510696"/>
-              <a:chOff x="570592" y="4006486"/>
-              <a:chExt cx="9807848" cy="6510696"/>
+              <a:off x="570592" y="4006485"/>
+              <a:ext cx="9807848" cy="5433637"/>
+              <a:chOff x="570592" y="4006485"/>
+              <a:chExt cx="9807848" cy="5433637"/>
             </a:xfrm>
           </p:grpSpPr>
           <p:sp>
@@ -3651,7 +3651,7 @@
             <p:spPr>
               <a:xfrm>
                 <a:off x="570592" y="4006486"/>
-                <a:ext cx="9807847" cy="6510696"/>
+                <a:ext cx="9807847" cy="5433636"/>
               </a:xfrm>
               <a:prstGeom prst="roundRect">
                 <a:avLst/>
@@ -3689,7 +3689,7 @@
             </p:nvSpPr>
             <p:spPr>
               <a:xfrm>
-                <a:off x="570594" y="4006486"/>
+                <a:off x="570594" y="4006485"/>
                 <a:ext cx="9807846" cy="1022714"/>
               </a:xfrm>
               <a:prstGeom prst="round2SameRect">
@@ -3748,8 +3748,8 @@
           </p:nvSpPr>
           <p:spPr>
             <a:xfrm>
-              <a:off x="822960" y="5196840"/>
-              <a:ext cx="9281160" cy="4989475"/>
+              <a:off x="822960" y="5196839"/>
+              <a:ext cx="9281160" cy="4243282"/>
             </a:xfrm>
             <a:prstGeom prst="rect">
               <a:avLst/>
@@ -3767,14 +3767,14 @@
                 <a:buChar char="§"/>
               </a:pPr>
               <a:r>
-                <a:rPr lang="en-GB" sz="2800" b="1" dirty="0"/>
+                <a:rPr lang="en-GB" sz="2400" b="1" dirty="0"/>
                 <a:t>Transfer Learning Between Problem Instances: </a:t>
               </a:r>
               <a:r>
-                <a:rPr lang="en-GB" sz="2800" dirty="0"/>
+                <a:rPr lang="en-GB" sz="2400" dirty="0"/>
                 <a:t>Allows hyper-heuristic exploit previously learning heuristic performance patterns</a:t>
               </a:r>
-              <a:endParaRPr lang="en-GB" sz="2800" b="1" dirty="0"/>
+              <a:endParaRPr lang="en-GB" sz="2400" b="1" dirty="0"/>
             </a:p>
             <a:p>
               <a:pPr marL="457200" indent="-457200">
@@ -3782,11 +3782,11 @@
                 <a:buChar char="§"/>
               </a:pPr>
               <a:r>
-                <a:rPr lang="en-GB" sz="2800" b="1" dirty="0"/>
+                <a:rPr lang="en-GB" sz="2400" b="1" dirty="0"/>
                 <a:t>Improving Early-Stage Solution Quality: </a:t>
               </a:r>
               <a:r>
-                <a:rPr lang="en-GB" sz="2800" dirty="0"/>
+                <a:rPr lang="en-GB" sz="2400" dirty="0"/>
                 <a:t>Helps hyper-heuristics prioritise heuristics that work well with similar </a:t>
               </a:r>
             </a:p>
@@ -3796,14 +3796,14 @@
                 <a:buChar char="§"/>
               </a:pPr>
               <a:r>
-                <a:rPr lang="en-GB" sz="2800" b="1" dirty="0"/>
+                <a:rPr lang="en-GB" sz="2400" b="1" dirty="0"/>
                 <a:t>Stabilise Heuristic Selection Behaviour: </a:t>
               </a:r>
               <a:r>
-                <a:rPr lang="en-GB" sz="2800" dirty="0"/>
+                <a:rPr lang="en-GB" sz="2400" dirty="0"/>
                 <a:t>Heuristic Selection is highly stochastic. Learns consistent patterns across multiple training runs</a:t>
               </a:r>
-              <a:endParaRPr lang="en-GB" sz="2800" b="1" dirty="0"/>
+              <a:endParaRPr lang="en-GB" sz="2400" b="1" dirty="0"/>
             </a:p>
           </p:txBody>
         </p:sp>
@@ -3941,7 +3941,7 @@
         <p:grpSpPr>
           <a:xfrm>
             <a:off x="422116" y="15698365"/>
-            <a:ext cx="20626882" cy="4690000"/>
+            <a:ext cx="20626882" cy="4904012"/>
             <a:chOff x="693255" y="19051859"/>
             <a:chExt cx="19997114" cy="8182785"/>
           </a:xfrm>
@@ -4044,6 +4044,275 @@
           </p:txBody>
         </p:sp>
       </p:grpSp>
+      <p:pic>
+        <p:nvPicPr>
+          <p:cNvPr id="31" name="Picture 30">
+            <a:extLst>
+              <a:ext uri="{FF2B5EF4-FFF2-40B4-BE49-F238E27FC236}">
+                <a16:creationId xmlns:a16="http://schemas.microsoft.com/office/drawing/2014/main" id="{CC8DF843-82BE-9790-128F-A42844D60F55}"/>
+              </a:ext>
+            </a:extLst>
+          </p:cNvPr>
+          <p:cNvPicPr>
+            <a:picLocks noChangeAspect="1"/>
+          </p:cNvPicPr>
+          <p:nvPr/>
+        </p:nvPicPr>
+        <p:blipFill>
+          <a:blip r:embed="rId3"/>
+          <a:stretch>
+            <a:fillRect/>
+          </a:stretch>
+        </p:blipFill>
+        <p:spPr>
+          <a:xfrm>
+            <a:off x="14137788" y="8566735"/>
+            <a:ext cx="6658708" cy="5931776"/>
+          </a:xfrm>
+          <a:prstGeom prst="rect">
+            <a:avLst/>
+          </a:prstGeom>
+        </p:spPr>
+      </p:pic>
+      <p:sp>
+        <p:nvSpPr>
+          <p:cNvPr id="28" name="TextBox 27">
+            <a:extLst>
+              <a:ext uri="{FF2B5EF4-FFF2-40B4-BE49-F238E27FC236}">
+                <a16:creationId xmlns:a16="http://schemas.microsoft.com/office/drawing/2014/main" id="{57ACA5CC-D355-A416-CE31-2E373E354A77}"/>
+              </a:ext>
+            </a:extLst>
+          </p:cNvPr>
+          <p:cNvSpPr txBox="1"/>
+          <p:nvPr/>
+        </p:nvSpPr>
+        <p:spPr>
+          <a:xfrm>
+            <a:off x="14841415" y="22230148"/>
+            <a:ext cx="5858729" cy="5159543"/>
+          </a:xfrm>
+          <a:prstGeom prst="rect">
+            <a:avLst/>
+          </a:prstGeom>
+          <a:noFill/>
+        </p:spPr>
+        <p:txBody>
+          <a:bodyPr wrap="square" rtlCol="0">
+            <a:noAutofit/>
+          </a:bodyPr>
+          <a:lstStyle/>
+          <a:p>
+            <a:pPr marL="285750" indent="-285750">
+              <a:buFont typeface="Arial" panose="020B0604020202020204" pitchFamily="34" charset="0"/>
+              <a:buChar char="•"/>
+            </a:pPr>
+            <a:r>
+              <a:rPr lang="en-GB" sz="2800" dirty="0"/>
+              <a:t>Results discussion in here</a:t>
+            </a:r>
+          </a:p>
+        </p:txBody>
+      </p:sp>
+      <p:pic>
+        <p:nvPicPr>
+          <p:cNvPr id="40" name="Picture 39">
+            <a:extLst>
+              <a:ext uri="{FF2B5EF4-FFF2-40B4-BE49-F238E27FC236}">
+                <a16:creationId xmlns:a16="http://schemas.microsoft.com/office/drawing/2014/main" id="{FE6A6E11-B29E-3453-8500-78CFC7923ACA}"/>
+              </a:ext>
+            </a:extLst>
+          </p:cNvPr>
+          <p:cNvPicPr>
+            <a:picLocks noChangeAspect="1"/>
+          </p:cNvPicPr>
+          <p:nvPr/>
+        </p:nvPicPr>
+        <p:blipFill>
+          <a:blip r:embed="rId4">
+            <a:extLst>
+              <a:ext uri="{28A0092B-C50C-407E-A947-70E740481C1C}">
+                <a14:useLocalDpi xmlns:a14="http://schemas.microsoft.com/office/drawing/2010/main" val="0"/>
+              </a:ext>
+            </a:extLst>
+          </a:blip>
+          <a:stretch>
+            <a:fillRect/>
+          </a:stretch>
+        </p:blipFill>
+        <p:spPr>
+          <a:xfrm>
+            <a:off x="674989" y="16684560"/>
+            <a:ext cx="13041005" cy="3617112"/>
+          </a:xfrm>
+          <a:prstGeom prst="rect">
+            <a:avLst/>
+          </a:prstGeom>
+        </p:spPr>
+      </p:pic>
+      <p:pic>
+        <p:nvPicPr>
+          <p:cNvPr id="41" name="Picture 2" descr="A new hyper-heuristic as a general problem solver: an implementation in  HyFlex | Journal of Scheduling">
+            <a:extLst>
+              <a:ext uri="{FF2B5EF4-FFF2-40B4-BE49-F238E27FC236}">
+                <a16:creationId xmlns:a16="http://schemas.microsoft.com/office/drawing/2014/main" id="{80DF5212-FD1B-B2A5-8DCA-1992D36D0C41}"/>
+              </a:ext>
+            </a:extLst>
+          </p:cNvPr>
+          <p:cNvPicPr>
+            <a:picLocks noChangeAspect="1" noChangeArrowheads="1"/>
+          </p:cNvPicPr>
+          <p:nvPr/>
+        </p:nvPicPr>
+        <p:blipFill>
+          <a:blip r:embed="rId5">
+            <a:extLst>
+              <a:ext uri="{28A0092B-C50C-407E-A947-70E740481C1C}">
+                <a14:useLocalDpi xmlns:a14="http://schemas.microsoft.com/office/drawing/2010/main" val="0"/>
+              </a:ext>
+            </a:extLst>
+          </a:blip>
+          <a:srcRect/>
+          <a:stretch>
+            <a:fillRect/>
+          </a:stretch>
+        </p:blipFill>
+        <p:spPr bwMode="auto">
+          <a:xfrm>
+            <a:off x="5191070" y="8566734"/>
+            <a:ext cx="8877860" cy="4175797"/>
+          </a:xfrm>
+          <a:prstGeom prst="rect">
+            <a:avLst/>
+          </a:prstGeom>
+          <a:noFill/>
+          <a:extLst>
+            <a:ext uri="{909E8E84-426E-40DD-AFC4-6F175D3DCCD1}">
+              <a14:hiddenFill xmlns:a14="http://schemas.microsoft.com/office/drawing/2010/main">
+                <a:solidFill>
+                  <a:srgbClr val="FFFFFF"/>
+                </a:solidFill>
+              </a14:hiddenFill>
+            </a:ext>
+          </a:extLst>
+        </p:spPr>
+      </p:pic>
+      <p:pic>
+        <p:nvPicPr>
+          <p:cNvPr id="1030" name="Picture 6">
+            <a:extLst>
+              <a:ext uri="{FF2B5EF4-FFF2-40B4-BE49-F238E27FC236}">
+                <a16:creationId xmlns:a16="http://schemas.microsoft.com/office/drawing/2014/main" id="{C5CC7F02-D693-154D-6124-7F25187C63D8}"/>
+              </a:ext>
+            </a:extLst>
+          </p:cNvPr>
+          <p:cNvPicPr>
+            <a:picLocks noChangeAspect="1" noChangeArrowheads="1"/>
+          </p:cNvPicPr>
+          <p:nvPr/>
+        </p:nvPicPr>
+        <p:blipFill>
+          <a:blip r:embed="rId6">
+            <a:extLst>
+              <a:ext uri="{28A0092B-C50C-407E-A947-70E740481C1C}">
+                <a14:useLocalDpi xmlns:a14="http://schemas.microsoft.com/office/drawing/2010/main" val="0"/>
+              </a:ext>
+            </a:extLst>
+          </a:blip>
+          <a:srcRect/>
+          <a:stretch>
+            <a:fillRect/>
+          </a:stretch>
+        </p:blipFill>
+        <p:spPr bwMode="auto">
+          <a:xfrm>
+            <a:off x="587129" y="8613359"/>
+            <a:ext cx="4505732" cy="3776623"/>
+          </a:xfrm>
+          <a:prstGeom prst="rect">
+            <a:avLst/>
+          </a:prstGeom>
+          <a:noFill/>
+          <a:extLst>
+            <a:ext uri="{909E8E84-426E-40DD-AFC4-6F175D3DCCD1}">
+              <a14:hiddenFill xmlns:a14="http://schemas.microsoft.com/office/drawing/2010/main">
+                <a:solidFill>
+                  <a:srgbClr val="FFFFFF"/>
+                </a:solidFill>
+              </a14:hiddenFill>
+            </a:ext>
+          </a:extLst>
+        </p:spPr>
+      </p:pic>
+      <p:sp>
+        <p:nvSpPr>
+          <p:cNvPr id="43" name="TextBox 42">
+            <a:extLst>
+              <a:ext uri="{FF2B5EF4-FFF2-40B4-BE49-F238E27FC236}">
+                <a16:creationId xmlns:a16="http://schemas.microsoft.com/office/drawing/2014/main" id="{3276E5ED-4682-145B-7F5B-20EDB0EB0424}"/>
+              </a:ext>
+            </a:extLst>
+          </p:cNvPr>
+          <p:cNvSpPr txBox="1"/>
+          <p:nvPr/>
+        </p:nvSpPr>
+        <p:spPr>
+          <a:xfrm>
+            <a:off x="7522524" y="12707608"/>
+            <a:ext cx="4183545" cy="371067"/>
+          </a:xfrm>
+          <a:prstGeom prst="rect">
+            <a:avLst/>
+          </a:prstGeom>
+          <a:noFill/>
+        </p:spPr>
+        <p:txBody>
+          <a:bodyPr wrap="square" rtlCol="0">
+            <a:spAutoFit/>
+          </a:bodyPr>
+          <a:lstStyle/>
+          <a:p>
+            <a:r>
+              <a:rPr lang="en-GB" dirty="0"/>
+              <a:t>[2] Selection Hyper-Heuristic Framework</a:t>
+            </a:r>
+          </a:p>
+        </p:txBody>
+      </p:sp>
+      <p:sp>
+        <p:nvSpPr>
+          <p:cNvPr id="44" name="TextBox 43">
+            <a:extLst>
+              <a:ext uri="{FF2B5EF4-FFF2-40B4-BE49-F238E27FC236}">
+                <a16:creationId xmlns:a16="http://schemas.microsoft.com/office/drawing/2014/main" id="{59C402B7-5265-6CB2-6FCB-4D0C7141C8AE}"/>
+              </a:ext>
+            </a:extLst>
+          </p:cNvPr>
+          <p:cNvSpPr txBox="1"/>
+          <p:nvPr/>
+        </p:nvSpPr>
+        <p:spPr>
+          <a:xfrm>
+            <a:off x="907260" y="12367905"/>
+            <a:ext cx="4183545" cy="371067"/>
+          </a:xfrm>
+          <a:prstGeom prst="rect">
+            <a:avLst/>
+          </a:prstGeom>
+          <a:noFill/>
+        </p:spPr>
+        <p:txBody>
+          <a:bodyPr wrap="square" rtlCol="0">
+            <a:spAutoFit/>
+          </a:bodyPr>
+          <a:lstStyle/>
+          <a:p>
+            <a:r>
+              <a:rPr lang="en-GB" dirty="0"/>
+              <a:t>[1] Generic Hyper-Heuristic Structure</a:t>
+            </a:r>
+          </a:p>
+        </p:txBody>
+      </p:sp>
     </p:spTree>
     <p:extLst>
       <p:ext uri="{BB962C8B-B14F-4D97-AF65-F5344CB8AC3E}">

</xml_diff>

<commit_message>
Initial test run of the pretrained hhyperheuristic, safeguard for if tensorflow/keras is turned on or is installed
</commit_message>
<xml_diff>
--- a/docs/Project A1 Poster.pptx
+++ b/docs/Project A1 Poster.pptx
@@ -2955,8 +2955,8 @@
         </p:nvSpPr>
         <p:spPr>
           <a:xfrm>
-            <a:off x="0" y="-18892"/>
-            <a:ext cx="21383625" cy="2812501"/>
+            <a:off x="0" y="-18891"/>
+            <a:ext cx="21383625" cy="2533204"/>
           </a:xfrm>
           <a:prstGeom prst="rect">
             <a:avLst/>
@@ -3008,8 +3008,8 @@
         </p:nvSpPr>
         <p:spPr>
           <a:xfrm>
-            <a:off x="3825656" y="107826"/>
-            <a:ext cx="16489458" cy="2635261"/>
+            <a:off x="3881035" y="200582"/>
+            <a:ext cx="16489458" cy="2198749"/>
           </a:xfrm>
         </p:spPr>
         <p:txBody>
@@ -3074,8 +3074,8 @@
         </p:blipFill>
         <p:spPr bwMode="auto">
           <a:xfrm>
-            <a:off x="693255" y="107826"/>
-            <a:ext cx="2665712" cy="2561684"/>
+            <a:off x="674989" y="151541"/>
+            <a:ext cx="2373380" cy="2280760"/>
           </a:xfrm>
           <a:prstGeom prst="rect">
             <a:avLst/>
@@ -3138,10 +3138,10 @@
         </p:nvGrpSpPr>
         <p:grpSpPr>
           <a:xfrm>
-            <a:off x="422116" y="7253603"/>
-            <a:ext cx="20534520" cy="8247533"/>
+            <a:off x="420306" y="6715095"/>
+            <a:ext cx="20534520" cy="8504145"/>
             <a:chOff x="570591" y="10666193"/>
-            <a:chExt cx="19997116" cy="8182786"/>
+            <a:chExt cx="19997116" cy="8328340"/>
           </a:xfrm>
         </p:grpSpPr>
         <p:sp>
@@ -3158,8 +3158,8 @@
           </p:nvSpPr>
           <p:spPr>
             <a:xfrm>
-              <a:off x="570593" y="10666194"/>
-              <a:ext cx="19997114" cy="8182785"/>
+              <a:off x="570593" y="10666193"/>
+              <a:ext cx="19997114" cy="8328340"/>
             </a:xfrm>
             <a:prstGeom prst="roundRect">
               <a:avLst/>
@@ -3198,7 +3198,7 @@
           <p:spPr>
             <a:xfrm>
               <a:off x="570591" y="10666193"/>
-              <a:ext cx="19997113" cy="1253050"/>
+              <a:ext cx="19997113" cy="1271259"/>
             </a:xfrm>
             <a:prstGeom prst="round2SameRect">
               <a:avLst/>
@@ -3256,8 +3256,8 @@
         </p:nvGrpSpPr>
         <p:grpSpPr>
           <a:xfrm>
-            <a:off x="422115" y="20851241"/>
-            <a:ext cx="20626880" cy="6899218"/>
+            <a:off x="422115" y="20810828"/>
+            <a:ext cx="20626880" cy="7069159"/>
             <a:chOff x="693255" y="19051859"/>
             <a:chExt cx="19997114" cy="8182785"/>
           </a:xfrm>
@@ -3374,10 +3374,10 @@
         </p:nvGrpSpPr>
         <p:grpSpPr>
           <a:xfrm>
-            <a:off x="10506232" y="3040569"/>
-            <a:ext cx="10450401" cy="4086944"/>
+            <a:off x="10511003" y="2615926"/>
+            <a:ext cx="10450401" cy="4093699"/>
             <a:chOff x="10503877" y="4006486"/>
-            <a:chExt cx="10186493" cy="6510696"/>
+            <a:chExt cx="10186493" cy="6606790"/>
           </a:xfrm>
         </p:grpSpPr>
         <p:grpSp>
@@ -3454,7 +3454,7 @@
             <p:spPr>
               <a:xfrm>
                 <a:off x="10503877" y="4006486"/>
-                <a:ext cx="10186492" cy="1022714"/>
+                <a:ext cx="10186492" cy="1022713"/>
               </a:xfrm>
               <a:prstGeom prst="round2SameRect">
                 <a:avLst/>
@@ -3489,14 +3489,7 @@
                     <a:latin typeface="Source Sans Pro Black" panose="020F0502020204030204" pitchFamily="34" charset="0"/>
                     <a:ea typeface="Source Sans Pro Black" panose="020F0502020204030204" pitchFamily="34" charset="0"/>
                   </a:rPr>
-                  <a:t>Aims </a:t>
-                </a:r>
-                <a:r>
-                  <a:rPr lang="en-GB" sz="4000">
-                    <a:latin typeface="Source Sans Pro Black" panose="020F0502020204030204" pitchFamily="34" charset="0"/>
-                    <a:ea typeface="Source Sans Pro Black" panose="020F0502020204030204" pitchFamily="34" charset="0"/>
-                  </a:rPr>
-                  <a:t>and Objectives</a:t>
+                  <a:t>Aims and Objectives</a:t>
                 </a:r>
                 <a:endParaRPr lang="en-GB" sz="3200" dirty="0">
                   <a:latin typeface="Source Sans Pro Black" panose="020F0502020204030204" pitchFamily="34" charset="0"/>
@@ -3519,8 +3512,8 @@
           </p:nvSpPr>
           <p:spPr>
             <a:xfrm>
-              <a:off x="10691812" y="5196840"/>
-              <a:ext cx="9748546" cy="4989475"/>
+              <a:off x="10691812" y="5196838"/>
+              <a:ext cx="9748546" cy="5416438"/>
             </a:xfrm>
             <a:prstGeom prst="rect">
               <a:avLst/>
@@ -3538,16 +3531,16 @@
                 <a:buChar char="Ø"/>
               </a:pPr>
               <a:r>
-                <a:rPr lang="en-GB" sz="2400" dirty="0"/>
+                <a:rPr lang="en-GB" sz="2200" dirty="0"/>
                 <a:t>Create and implement a </a:t>
               </a:r>
               <a:r>
-                <a:rPr lang="en-GB" sz="2400" dirty="0" err="1"/>
+                <a:rPr lang="en-GB" sz="2200" dirty="0" err="1"/>
                 <a:t>hyperheuristic</a:t>
               </a:r>
               <a:r>
-                <a:rPr lang="en-GB" sz="2400" dirty="0"/>
-                <a:t> that operates on the problem domains in Hyflex</a:t>
+                <a:rPr lang="en-GB" sz="2200" dirty="0"/>
+                <a:t> that operates on the problem domains in Hyflex [1], using low-level heuristic selection and acceptance methods.</a:t>
               </a:r>
             </a:p>
             <a:p>
@@ -3556,16 +3549,16 @@
                 <a:buChar char="Ø"/>
               </a:pPr>
               <a:r>
-                <a:rPr lang="en-GB" sz="2400" dirty="0"/>
+                <a:rPr lang="en-GB" sz="2200" dirty="0"/>
                 <a:t>Attach a Python-Java Gateway that runs Hyflex </a:t>
               </a:r>
               <a:r>
-                <a:rPr lang="en-GB" sz="2400" dirty="0" err="1"/>
+                <a:rPr lang="en-GB" sz="2200" dirty="0" err="1"/>
                 <a:t>hyperheuristics</a:t>
               </a:r>
               <a:r>
-                <a:rPr lang="en-GB" sz="2400" dirty="0"/>
-                <a:t> on the problem domains to visually compare results</a:t>
+                <a:rPr lang="en-GB" sz="2200" dirty="0"/>
+                <a:t> on the problem domains to visually compare results across multiple runs and instances.</a:t>
               </a:r>
             </a:p>
             <a:p>
@@ -3574,24 +3567,17 @@
                 <a:buChar char="Ø"/>
               </a:pPr>
               <a:r>
-                <a:rPr lang="en-GB" sz="2400" dirty="0"/>
+                <a:rPr lang="en-GB" sz="2200" dirty="0"/>
                 <a:t>Attempt to see if pre-training a </a:t>
               </a:r>
               <a:r>
-                <a:rPr lang="en-GB" sz="2400" dirty="0" err="1"/>
+                <a:rPr lang="en-GB" sz="2200" dirty="0" err="1"/>
                 <a:t>hyperheuristic</a:t>
               </a:r>
               <a:r>
-                <a:rPr lang="en-GB" sz="2400" dirty="0"/>
-                <a:t> is achievable</a:t>
+                <a:rPr lang="en-GB" sz="2200" dirty="0"/>
+                <a:t> is achievable by leveraging prior experience from known problem domains to improve performance on unseen instances.</a:t>
               </a:r>
-            </a:p>
-            <a:p>
-              <a:pPr marL="457200" indent="-457200">
-                <a:buFont typeface="Wingdings" panose="05000000000000000000" pitchFamily="2" charset="2"/>
-                <a:buChar char="§"/>
-              </a:pPr>
-              <a:endParaRPr lang="en-GB" sz="2800" dirty="0"/>
             </a:p>
           </p:txBody>
         </p:sp>
@@ -3610,10 +3596,10 @@
         </p:nvGrpSpPr>
         <p:grpSpPr>
           <a:xfrm>
-            <a:off x="422115" y="3040569"/>
-            <a:ext cx="9827523" cy="4086945"/>
-            <a:chOff x="570592" y="4006485"/>
-            <a:chExt cx="9807848" cy="5433637"/>
+            <a:off x="422219" y="2621395"/>
+            <a:ext cx="9827523" cy="4034157"/>
+            <a:chOff x="570592" y="4006486"/>
+            <a:chExt cx="9807848" cy="5433636"/>
           </a:xfrm>
         </p:grpSpPr>
         <p:grpSp>
@@ -3630,10 +3616,10 @@
           </p:nvGrpSpPr>
           <p:grpSpPr>
             <a:xfrm>
-              <a:off x="570592" y="4006485"/>
-              <a:ext cx="9807848" cy="5433637"/>
-              <a:chOff x="570592" y="4006485"/>
-              <a:chExt cx="9807848" cy="5433637"/>
+              <a:off x="570592" y="4006486"/>
+              <a:ext cx="9807848" cy="5433636"/>
+              <a:chOff x="570592" y="4006486"/>
+              <a:chExt cx="9807848" cy="5433636"/>
             </a:xfrm>
           </p:grpSpPr>
           <p:sp>
@@ -3689,8 +3675,8 @@
             </p:nvSpPr>
             <p:spPr>
               <a:xfrm>
-                <a:off x="570594" y="4006485"/>
-                <a:ext cx="9807846" cy="1022714"/>
+                <a:off x="570594" y="4006486"/>
+                <a:ext cx="9807846" cy="892782"/>
               </a:xfrm>
               <a:prstGeom prst="round2SameRect">
                 <a:avLst/>
@@ -3748,7 +3734,7 @@
           </p:nvSpPr>
           <p:spPr>
             <a:xfrm>
-              <a:off x="822960" y="5196839"/>
+              <a:off x="822960" y="5070894"/>
               <a:ext cx="9281160" cy="4243282"/>
             </a:xfrm>
             <a:prstGeom prst="rect">
@@ -3940,8 +3926,8 @@
         </p:nvGrpSpPr>
         <p:grpSpPr>
           <a:xfrm>
-            <a:off x="422116" y="15698365"/>
-            <a:ext cx="20626882" cy="4904012"/>
+            <a:off x="422116" y="15278784"/>
+            <a:ext cx="20626882" cy="5419408"/>
             <a:chOff x="693255" y="19051859"/>
             <a:chExt cx="19997114" cy="8182785"/>
           </a:xfrm>
@@ -4066,7 +4052,7 @@
         </p:blipFill>
         <p:spPr>
           <a:xfrm>
-            <a:off x="14137788" y="8566735"/>
+            <a:off x="6844154" y="8042926"/>
             <a:ext cx="6658708" cy="5931776"/>
           </a:xfrm>
           <a:prstGeom prst="rect">
@@ -4141,8 +4127,8 @@
         </p:blipFill>
         <p:spPr>
           <a:xfrm>
-            <a:off x="674989" y="16684560"/>
-            <a:ext cx="13041005" cy="3617112"/>
+            <a:off x="10911841" y="17825653"/>
+            <a:ext cx="9646920" cy="2675713"/>
           </a:xfrm>
           <a:prstGeom prst="rect">
             <a:avLst/>
@@ -4151,10 +4137,10 @@
       </p:pic>
       <p:pic>
         <p:nvPicPr>
-          <p:cNvPr id="41" name="Picture 2" descr="A new hyper-heuristic as a general problem solver: an implementation in  HyFlex | Journal of Scheduling">
+          <p:cNvPr id="1030" name="Picture 6">
             <a:extLst>
               <a:ext uri="{FF2B5EF4-FFF2-40B4-BE49-F238E27FC236}">
-                <a16:creationId xmlns:a16="http://schemas.microsoft.com/office/drawing/2014/main" id="{80DF5212-FD1B-B2A5-8DCA-1992D36D0C41}"/>
+                <a16:creationId xmlns:a16="http://schemas.microsoft.com/office/drawing/2014/main" id="{C5CC7F02-D693-154D-6124-7F25187C63D8}"/>
               </a:ext>
             </a:extLst>
           </p:cNvPr>
@@ -4178,8 +4164,8 @@
         </p:blipFill>
         <p:spPr bwMode="auto">
           <a:xfrm>
-            <a:off x="5191070" y="8566734"/>
-            <a:ext cx="8877860" cy="4175797"/>
+            <a:off x="897497" y="8275701"/>
+            <a:ext cx="5280271" cy="4425828"/>
           </a:xfrm>
           <a:prstGeom prst="rect">
             <a:avLst/>
@@ -4196,88 +4182,6 @@
           </a:extLst>
         </p:spPr>
       </p:pic>
-      <p:pic>
-        <p:nvPicPr>
-          <p:cNvPr id="1030" name="Picture 6">
-            <a:extLst>
-              <a:ext uri="{FF2B5EF4-FFF2-40B4-BE49-F238E27FC236}">
-                <a16:creationId xmlns:a16="http://schemas.microsoft.com/office/drawing/2014/main" id="{C5CC7F02-D693-154D-6124-7F25187C63D8}"/>
-              </a:ext>
-            </a:extLst>
-          </p:cNvPr>
-          <p:cNvPicPr>
-            <a:picLocks noChangeAspect="1" noChangeArrowheads="1"/>
-          </p:cNvPicPr>
-          <p:nvPr/>
-        </p:nvPicPr>
-        <p:blipFill>
-          <a:blip r:embed="rId6">
-            <a:extLst>
-              <a:ext uri="{28A0092B-C50C-407E-A947-70E740481C1C}">
-                <a14:useLocalDpi xmlns:a14="http://schemas.microsoft.com/office/drawing/2010/main" val="0"/>
-              </a:ext>
-            </a:extLst>
-          </a:blip>
-          <a:srcRect/>
-          <a:stretch>
-            <a:fillRect/>
-          </a:stretch>
-        </p:blipFill>
-        <p:spPr bwMode="auto">
-          <a:xfrm>
-            <a:off x="587129" y="8613359"/>
-            <a:ext cx="4505732" cy="3776623"/>
-          </a:xfrm>
-          <a:prstGeom prst="rect">
-            <a:avLst/>
-          </a:prstGeom>
-          <a:noFill/>
-          <a:extLst>
-            <a:ext uri="{909E8E84-426E-40DD-AFC4-6F175D3DCCD1}">
-              <a14:hiddenFill xmlns:a14="http://schemas.microsoft.com/office/drawing/2010/main">
-                <a:solidFill>
-                  <a:srgbClr val="FFFFFF"/>
-                </a:solidFill>
-              </a14:hiddenFill>
-            </a:ext>
-          </a:extLst>
-        </p:spPr>
-      </p:pic>
-      <p:sp>
-        <p:nvSpPr>
-          <p:cNvPr id="43" name="TextBox 42">
-            <a:extLst>
-              <a:ext uri="{FF2B5EF4-FFF2-40B4-BE49-F238E27FC236}">
-                <a16:creationId xmlns:a16="http://schemas.microsoft.com/office/drawing/2014/main" id="{3276E5ED-4682-145B-7F5B-20EDB0EB0424}"/>
-              </a:ext>
-            </a:extLst>
-          </p:cNvPr>
-          <p:cNvSpPr txBox="1"/>
-          <p:nvPr/>
-        </p:nvSpPr>
-        <p:spPr>
-          <a:xfrm>
-            <a:off x="7522524" y="12707608"/>
-            <a:ext cx="4183545" cy="371067"/>
-          </a:xfrm>
-          <a:prstGeom prst="rect">
-            <a:avLst/>
-          </a:prstGeom>
-          <a:noFill/>
-        </p:spPr>
-        <p:txBody>
-          <a:bodyPr wrap="square" rtlCol="0">
-            <a:spAutoFit/>
-          </a:bodyPr>
-          <a:lstStyle/>
-          <a:p>
-            <a:r>
-              <a:rPr lang="en-GB" dirty="0"/>
-              <a:t>[2] Selection Hyper-Heuristic Framework</a:t>
-            </a:r>
-          </a:p>
-        </p:txBody>
-      </p:sp>
       <p:sp>
         <p:nvSpPr>
           <p:cNvPr id="44" name="TextBox 43">
@@ -4292,7 +4196,7 @@
         </p:nvSpPr>
         <p:spPr>
           <a:xfrm>
-            <a:off x="907260" y="12367905"/>
+            <a:off x="1445859" y="12761072"/>
             <a:ext cx="4183545" cy="371067"/>
           </a:xfrm>
           <a:prstGeom prst="rect">
@@ -4308,11 +4212,288 @@
           <a:p>
             <a:r>
               <a:rPr lang="en-GB" dirty="0"/>
-              <a:t>[1] Generic Hyper-Heuristic Structure</a:t>
-            </a:r>
-          </a:p>
-        </p:txBody>
-      </p:sp>
+              <a:t>[2] Generic Hyper-Heuristic Structure</a:t>
+            </a:r>
+          </a:p>
+        </p:txBody>
+      </p:sp>
+      <p:sp>
+        <p:nvSpPr>
+          <p:cNvPr id="29" name="TextBox 28">
+            <a:extLst>
+              <a:ext uri="{FF2B5EF4-FFF2-40B4-BE49-F238E27FC236}">
+                <a16:creationId xmlns:a16="http://schemas.microsoft.com/office/drawing/2014/main" id="{0067A7B6-AD0C-708C-5D8A-9B07665E272B}"/>
+              </a:ext>
+            </a:extLst>
+          </p:cNvPr>
+          <p:cNvSpPr txBox="1"/>
+          <p:nvPr/>
+        </p:nvSpPr>
+        <p:spPr>
+          <a:xfrm>
+            <a:off x="674989" y="28780804"/>
+            <a:ext cx="20025155" cy="925473"/>
+          </a:xfrm>
+          <a:prstGeom prst="rect">
+            <a:avLst/>
+          </a:prstGeom>
+          <a:noFill/>
+        </p:spPr>
+        <p:txBody>
+          <a:bodyPr wrap="square" rtlCol="0">
+            <a:noAutofit/>
+          </a:bodyPr>
+          <a:lstStyle/>
+          <a:p>
+            <a:r>
+              <a:rPr lang="en-GB" dirty="0"/>
+              <a:t>[1] - </a:t>
+            </a:r>
+            <a:r>
+              <a:rPr lang="en-GB" dirty="0" err="1"/>
+              <a:t>seage</a:t>
+            </a:r>
+            <a:r>
+              <a:rPr lang="en-GB" dirty="0"/>
+              <a:t>. 2025. “GitHub - Seage/Hyflex: Some Hyper-</a:t>
+            </a:r>
+            <a:r>
+              <a:rPr lang="en-GB" dirty="0" err="1"/>
+              <a:t>Heurisics</a:t>
+            </a:r>
+            <a:r>
+              <a:rPr lang="en-GB" dirty="0"/>
+              <a:t> from </a:t>
+            </a:r>
+            <a:r>
+              <a:rPr lang="en-GB" dirty="0" err="1"/>
+              <a:t>CHeSC</a:t>
+            </a:r>
+            <a:r>
+              <a:rPr lang="en-GB" dirty="0"/>
+              <a:t> 2011 Challenge and the Challenge Results Reproducing Attempts.” GitHub. 2025. </a:t>
+            </a:r>
+            <a:r>
+              <a:rPr lang="en-GB" dirty="0">
+                <a:hlinkClick r:id="rId6"/>
+              </a:rPr>
+              <a:t>https://github.com/seage/hyflex</a:t>
+            </a:r>
+            <a:r>
+              <a:rPr lang="en-GB" dirty="0"/>
+              <a:t>.</a:t>
+            </a:r>
+          </a:p>
+          <a:p>
+            <a:r>
+              <a:rPr lang="en-GB" dirty="0"/>
+              <a:t>[2] - </a:t>
+            </a:r>
+          </a:p>
+          <a:p>
+            <a:r>
+              <a:rPr lang="en-GB" dirty="0"/>
+              <a:t>[3] - </a:t>
+            </a:r>
+          </a:p>
+        </p:txBody>
+      </p:sp>
+      <p:cxnSp>
+        <p:nvCxnSpPr>
+          <p:cNvPr id="32" name="Straight Connector 31">
+            <a:extLst>
+              <a:ext uri="{FF2B5EF4-FFF2-40B4-BE49-F238E27FC236}">
+                <a16:creationId xmlns:a16="http://schemas.microsoft.com/office/drawing/2014/main" id="{D7E33F01-AB3D-AFF6-D38E-16F5842BA48B}"/>
+              </a:ext>
+            </a:extLst>
+          </p:cNvPr>
+          <p:cNvCxnSpPr>
+            <a:stCxn id="26" idx="1"/>
+            <a:endCxn id="25" idx="2"/>
+          </p:cNvCxnSpPr>
+          <p:nvPr/>
+        </p:nvCxnSpPr>
+        <p:spPr>
+          <a:xfrm flipH="1">
+            <a:off x="10735557" y="16105137"/>
+            <a:ext cx="1" cy="4593055"/>
+          </a:xfrm>
+          <a:prstGeom prst="line">
+            <a:avLst/>
+          </a:prstGeom>
+          <a:ln w="38100">
+            <a:solidFill>
+              <a:schemeClr val="tx1"/>
+            </a:solidFill>
+          </a:ln>
+        </p:spPr>
+        <p:style>
+          <a:lnRef idx="2">
+            <a:schemeClr val="dk1"/>
+          </a:lnRef>
+          <a:fillRef idx="0">
+            <a:schemeClr val="dk1"/>
+          </a:fillRef>
+          <a:effectRef idx="1">
+            <a:schemeClr val="dk1"/>
+          </a:effectRef>
+          <a:fontRef idx="minor">
+            <a:schemeClr val="tx1"/>
+          </a:fontRef>
+        </p:style>
+      </p:cxnSp>
+      <p:sp>
+        <p:nvSpPr>
+          <p:cNvPr id="33" name="TextBox 32">
+            <a:extLst>
+              <a:ext uri="{FF2B5EF4-FFF2-40B4-BE49-F238E27FC236}">
+                <a16:creationId xmlns:a16="http://schemas.microsoft.com/office/drawing/2014/main" id="{2EEDB874-4C40-C5BF-F99D-095968D05142}"/>
+              </a:ext>
+            </a:extLst>
+          </p:cNvPr>
+          <p:cNvSpPr txBox="1"/>
+          <p:nvPr/>
+        </p:nvSpPr>
+        <p:spPr>
+          <a:xfrm>
+            <a:off x="1147429" y="14184670"/>
+            <a:ext cx="5812897" cy="891024"/>
+          </a:xfrm>
+          <a:prstGeom prst="rect">
+            <a:avLst/>
+          </a:prstGeom>
+          <a:noFill/>
+        </p:spPr>
+        <p:txBody>
+          <a:bodyPr wrap="square" rtlCol="0">
+            <a:noAutofit/>
+          </a:bodyPr>
+          <a:lstStyle/>
+          <a:p>
+            <a:r>
+              <a:rPr lang="en-GB" sz="2000" dirty="0" err="1"/>
+              <a:t>Hyperheuristic</a:t>
+            </a:r>
+            <a:r>
+              <a:rPr lang="en-GB" sz="2000" dirty="0"/>
+              <a:t> build using </a:t>
+            </a:r>
+          </a:p>
+        </p:txBody>
+      </p:sp>
+      <p:sp>
+        <p:nvSpPr>
+          <p:cNvPr id="34" name="TextBox 33">
+            <a:extLst>
+              <a:ext uri="{FF2B5EF4-FFF2-40B4-BE49-F238E27FC236}">
+                <a16:creationId xmlns:a16="http://schemas.microsoft.com/office/drawing/2014/main" id="{6CB65CAB-AAF8-1B9E-8502-64ADC0D0B527}"/>
+              </a:ext>
+            </a:extLst>
+          </p:cNvPr>
+          <p:cNvSpPr txBox="1"/>
+          <p:nvPr/>
+        </p:nvSpPr>
+        <p:spPr>
+          <a:xfrm>
+            <a:off x="12564874" y="16042011"/>
+            <a:ext cx="6353905" cy="536753"/>
+          </a:xfrm>
+          <a:prstGeom prst="rect">
+            <a:avLst/>
+          </a:prstGeom>
+          <a:noFill/>
+        </p:spPr>
+        <p:txBody>
+          <a:bodyPr wrap="square" rtlCol="0" anchor="ctr" anchorCtr="0">
+            <a:noAutofit/>
+          </a:bodyPr>
+          <a:lstStyle/>
+          <a:p>
+            <a:pPr algn="ctr"/>
+            <a:r>
+              <a:rPr lang="en-GB" b="1" dirty="0"/>
+              <a:t>Pre-Training </a:t>
+            </a:r>
+            <a:r>
+              <a:rPr lang="en-GB" b="1" dirty="0" err="1"/>
+              <a:t>Hyperheuristic</a:t>
+            </a:r>
+            <a:endParaRPr lang="en-GB" b="1" dirty="0"/>
+          </a:p>
+        </p:txBody>
+      </p:sp>
+      <p:sp>
+        <p:nvSpPr>
+          <p:cNvPr id="35" name="TextBox 34">
+            <a:extLst>
+              <a:ext uri="{FF2B5EF4-FFF2-40B4-BE49-F238E27FC236}">
+                <a16:creationId xmlns:a16="http://schemas.microsoft.com/office/drawing/2014/main" id="{A01335E3-7F94-AD93-4881-5E04A17BBA67}"/>
+              </a:ext>
+            </a:extLst>
+          </p:cNvPr>
+          <p:cNvSpPr txBox="1"/>
+          <p:nvPr/>
+        </p:nvSpPr>
+        <p:spPr>
+          <a:xfrm>
+            <a:off x="2159027" y="16007467"/>
+            <a:ext cx="6353905" cy="536753"/>
+          </a:xfrm>
+          <a:prstGeom prst="rect">
+            <a:avLst/>
+          </a:prstGeom>
+          <a:noFill/>
+        </p:spPr>
+        <p:txBody>
+          <a:bodyPr wrap="square" rtlCol="0" anchor="ctr" anchorCtr="0">
+            <a:noAutofit/>
+          </a:bodyPr>
+          <a:lstStyle/>
+          <a:p>
+            <a:pPr algn="ctr"/>
+            <a:r>
+              <a:rPr lang="en-GB" b="1" dirty="0"/>
+              <a:t>Py4J Java Gateway</a:t>
+            </a:r>
+          </a:p>
+        </p:txBody>
+      </p:sp>
+      <p:pic>
+        <p:nvPicPr>
+          <p:cNvPr id="49" name="Picture 48">
+            <a:extLst>
+              <a:ext uri="{FF2B5EF4-FFF2-40B4-BE49-F238E27FC236}">
+                <a16:creationId xmlns:a16="http://schemas.microsoft.com/office/drawing/2014/main" id="{494D7A6B-3D11-341F-24C9-EDDFB59D0D86}"/>
+              </a:ext>
+            </a:extLst>
+          </p:cNvPr>
+          <p:cNvPicPr>
+            <a:picLocks noChangeAspect="1"/>
+          </p:cNvPicPr>
+          <p:nvPr/>
+        </p:nvPicPr>
+        <p:blipFill>
+          <a:blip r:embed="rId7">
+            <a:extLst>
+              <a:ext uri="{28A0092B-C50C-407E-A947-70E740481C1C}">
+                <a14:useLocalDpi xmlns:a14="http://schemas.microsoft.com/office/drawing/2010/main" val="0"/>
+              </a:ext>
+            </a:extLst>
+          </a:blip>
+          <a:stretch>
+            <a:fillRect/>
+          </a:stretch>
+        </p:blipFill>
+        <p:spPr>
+          <a:xfrm>
+            <a:off x="14051226" y="8293516"/>
+            <a:ext cx="6507535" cy="5023899"/>
+          </a:xfrm>
+          <a:prstGeom prst="rect">
+            <a:avLst/>
+          </a:prstGeom>
+        </p:spPr>
+      </p:pic>
     </p:spTree>
     <p:extLst>
       <p:ext uri="{BB962C8B-B14F-4D97-AF65-F5344CB8AC3E}">

</xml_diff>